<commit_message>
Add demo video, update slides, rewrite root README for full repo
README now covers all deliverables (report, slides, video, POC) and
describes the full repo rather than just the cotiviti_poc subfolder.

Co-Authored-By: Claude Sonnet 4.6 <noreply@anthropic.com>
</commit_message>
<xml_diff>
--- a/Cotiviti_Slides_Aryan_Maheshwari.pptx
+++ b/Cotiviti_Slides_Aryan_Maheshwari.pptx
@@ -4,6 +4,9 @@
   <p:sldMasterIdLst>
     <p:sldMasterId id="2147483648" r:id="rId1"/>
   </p:sldMasterIdLst>
+  <p:notesMasterIdLst>
+    <p:notesMasterId r:id="rId12"/>
+  </p:notesMasterIdLst>
   <p:sldIdLst>
     <p:sldId id="256" r:id="rId2"/>
     <p:sldId id="257" r:id="rId3"/>
@@ -16,9 +19,6 @@
     <p:sldId id="264" r:id="rId10"/>
     <p:sldId id="265" r:id="rId11"/>
   </p:sldIdLst>
-  <p:notesMasterIdLst>
-    <p:notesMasterId r:id="rId12"/>
-  </p:notesMasterIdLst>
   <p:sldSz cx="12192000" cy="6858000"/>
   <p:notesSz cx="6858000" cy="12192000"/>
   <p:defaultTextStyle>
@@ -113,6 +113,11 @@
       </a:defRPr>
     </a:lvl9pPr>
   </p:defaultTextStyle>
+  <p:extLst>
+    <p:ext uri="{EFAFB233-063F-42B5-8137-9DF3F51BA10A}">
+      <p15:sldGuideLst xmlns:p15="http://schemas.microsoft.com/office/powerpoint/2012/main"/>
+    </p:ext>
+  </p:extLst>
 </p:presentation>
 </file>
 
@@ -138,234 +143,10 @@
           <a:chExt cx="0" cy="0"/>
         </a:xfrm>
       </p:grpSpPr>
-      <p:sp>
-        <p:nvSpPr>
-          <p:cNvPr id="2" name="Header Placeholder 1"/>
-          <p:cNvSpPr>
-            <a:spLocks noGrp="1"/>
-          </p:cNvSpPr>
-          <p:nvPr>
-            <p:ph type="hdr" sz="quarter"/>
-          </p:nvPr>
-        </p:nvSpPr>
-        <p:spPr>
-          <a:xfrm>
-            <a:off x="0" y="0"/>
-            <a:ext cx="2971800" cy="458788"/>
-          </a:xfrm>
-          <a:prstGeom prst="rect">
-            <a:avLst/>
-          </a:prstGeom>
-        </p:spPr>
-        <p:txBody>
-          <a:bodyPr vert="horz" lIns="91440" tIns="45720" rIns="91440" bIns="45720" rtlCol="0"/>
-          <a:lstStyle>
-            <a:lvl1pPr algn="l">
-              <a:defRPr sz="1200"/>
-            </a:lvl1pPr>
-          </a:lstStyle>
-          <a:p>
-            <a:endParaRPr lang="en-US"/>
-          </a:p>
-        </p:txBody>
-      </p:sp>
-      <p:sp>
-        <p:nvSpPr>
-          <p:cNvPr id="3" name="Date Placeholder 2"/>
-          <p:cNvSpPr>
-            <a:spLocks noGrp="1"/>
-          </p:cNvSpPr>
-          <p:nvPr>
-            <p:ph type="dt" idx="1"/>
-          </p:nvPr>
-        </p:nvSpPr>
-        <p:spPr>
-          <a:xfrm>
-            <a:off x="3884613" y="0"/>
-            <a:ext cx="2971800" cy="458788"/>
-          </a:xfrm>
-          <a:prstGeom prst="rect">
-            <a:avLst/>
-          </a:prstGeom>
-        </p:spPr>
-        <p:txBody>
-          <a:bodyPr vert="horz" lIns="91440" tIns="45720" rIns="91440" bIns="45720" rtlCol="0"/>
-          <a:lstStyle>
-            <a:lvl1pPr algn="r">
-              <a:defRPr sz="1200"/>
-            </a:lvl1pPr>
-          </a:lstStyle>
-          <a:p>
-            <a:fld id="{5282F153-3F37-0F45-9E97-73ACFA13230C}" type="datetimeFigureOut">
-              <a:rPr lang="en-US"/>
-              <a:t>7/23/19</a:t>
-            </a:fld>
-            <a:endParaRPr lang="en-US"/>
-          </a:p>
-        </p:txBody>
-      </p:sp>
-      <p:sp>
-        <p:nvSpPr>
-          <p:cNvPr id="4" name="Slide Image Placeholder 3"/>
-          <p:cNvSpPr>
-            <a:spLocks noGrp="1" noRot="1" noChangeAspect="1"/>
-          </p:cNvSpPr>
-          <p:nvPr>
-            <p:ph type="sldImg" idx="2"/>
-          </p:nvPr>
-        </p:nvSpPr>
-        <p:spPr>
-          <a:xfrm>
-            <a:off x="685800" y="1143000"/>
-            <a:ext cx="5486400" cy="3086100"/>
-          </a:xfrm>
-          <a:prstGeom prst="rect">
-            <a:avLst/>
-          </a:prstGeom>
-          <a:noFill/>
-          <a:ln w="12700">
-            <a:solidFill>
-              <a:prstClr val="black"/>
-            </a:solidFill>
-          </a:ln>
-        </p:spPr>
-        <p:txBody>
-          <a:bodyPr vert="horz" lIns="91440" tIns="45720" rIns="91440" bIns="45720" rtlCol="0" anchor="ctr"/>
-          <a:lstStyle/>
-          <a:p>
-            <a:endParaRPr lang="en-US"/>
-          </a:p>
-        </p:txBody>
-      </p:sp>
-      <p:sp>
-        <p:nvSpPr>
-          <p:cNvPr id="5" name="Notes Placeholder 4"/>
-          <p:cNvSpPr>
-            <a:spLocks noGrp="1"/>
-          </p:cNvSpPr>
-          <p:nvPr>
-            <p:ph type="body" sz="quarter" idx="3"/>
-          </p:nvPr>
-        </p:nvSpPr>
-        <p:spPr>
-          <a:xfrm>
-            <a:off x="685800" y="4400550"/>
-            <a:ext cx="5486400" cy="3600450"/>
-          </a:xfrm>
-          <a:prstGeom prst="rect">
-            <a:avLst/>
-          </a:prstGeom>
-        </p:spPr>
-        <p:txBody>
-          <a:bodyPr vert="horz" lIns="91440" tIns="45720" rIns="91440" bIns="45720" rtlCol="0"/>
-          <a:lstStyle/>
-          <a:p>
-            <a:pPr lvl="0"/>
-            <a:r>
-              <a:rPr lang="en-US"/>
-              <a:t>Click to edit Master text styles</a:t>
-            </a:r>
-          </a:p>
-          <a:p>
-            <a:pPr lvl="1"/>
-            <a:r>
-              <a:rPr lang="en-US"/>
-              <a:t>Second level</a:t>
-            </a:r>
-          </a:p>
-          <a:p>
-            <a:pPr lvl="2"/>
-            <a:r>
-              <a:rPr lang="en-US"/>
-              <a:t>Third level</a:t>
-            </a:r>
-          </a:p>
-          <a:p>
-            <a:pPr lvl="3"/>
-            <a:r>
-              <a:rPr lang="en-US"/>
-              <a:t>Fourth level</a:t>
-            </a:r>
-          </a:p>
-          <a:p>
-            <a:pPr lvl="4"/>
-            <a:r>
-              <a:rPr lang="en-US"/>
-              <a:t>Fifth level</a:t>
-            </a:r>
-          </a:p>
-        </p:txBody>
-      </p:sp>
-      <p:sp>
-        <p:nvSpPr>
-          <p:cNvPr id="6" name="Footer Placeholder 5"/>
-          <p:cNvSpPr>
-            <a:spLocks noGrp="1"/>
-          </p:cNvSpPr>
-          <p:nvPr>
-            <p:ph type="ftr" sz="quarter" idx="4"/>
-          </p:nvPr>
-        </p:nvSpPr>
-        <p:spPr>
-          <a:xfrm>
-            <a:off x="0" y="8685213"/>
-            <a:ext cx="2971800" cy="458787"/>
-          </a:xfrm>
-          <a:prstGeom prst="rect">
-            <a:avLst/>
-          </a:prstGeom>
-        </p:spPr>
-        <p:txBody>
-          <a:bodyPr vert="horz" lIns="91440" tIns="45720" rIns="91440" bIns="45720" rtlCol="0" anchor="b"/>
-          <a:lstStyle>
-            <a:lvl1pPr algn="l">
-              <a:defRPr sz="1200"/>
-            </a:lvl1pPr>
-          </a:lstStyle>
-          <a:p>
-            <a:endParaRPr lang="en-US"/>
-          </a:p>
-        </p:txBody>
-      </p:sp>
-      <p:sp>
-        <p:nvSpPr>
-          <p:cNvPr id="7" name="Slide Number Placeholder 6"/>
-          <p:cNvSpPr>
-            <a:spLocks noGrp="1"/>
-          </p:cNvSpPr>
-          <p:nvPr>
-            <p:ph type="sldNum" sz="quarter" idx="5"/>
-          </p:nvPr>
-        </p:nvSpPr>
-        <p:spPr>
-          <a:xfrm>
-            <a:off x="3884613" y="8685213"/>
-            <a:ext cx="2971800" cy="458787"/>
-          </a:xfrm>
-          <a:prstGeom prst="rect">
-            <a:avLst/>
-          </a:prstGeom>
-        </p:spPr>
-        <p:txBody>
-          <a:bodyPr vert="horz" lIns="91440" tIns="45720" rIns="91440" bIns="45720" rtlCol="0" anchor="b"/>
-          <a:lstStyle>
-            <a:lvl1pPr algn="r">
-              <a:defRPr sz="1200"/>
-            </a:lvl1pPr>
-          </a:lstStyle>
-          <a:p>
-            <a:fld id="{CE5E9CC1-C706-0F49-92D6-E571CC5EEA8F}" type="slidenum">
-              <a:rPr lang="en-US"/>
-              <a:t>‹#›</a:t>
-            </a:fld>
-            <a:endParaRPr lang="en-US"/>
-          </a:p>
-        </p:txBody>
-      </p:sp>
     </p:spTree>
     <p:extLst>
       <p:ext uri="{BB962C8B-B14F-4D97-AF65-F5344CB8AC3E}">
-        <p14:creationId xmlns:p14="http://schemas.microsoft.com/office/powerpoint/2010/main" val="1024086991"/>
+        <p14:creationId xmlns:p14="http://schemas.microsoft.com/office/powerpoint/2010/main" val="3361224712"/>
       </p:ext>
     </p:extLst>
   </p:cSld>
@@ -509,10 +290,6 @@
           <a:bodyPr/>
           <a:lstStyle/>
           <a:p>
-            <a:r>
-              <a:rPr lang="en-US" dirty="0"/>
-              <a:t/>
-            </a:r>
             <a:endParaRPr lang="en-US" dirty="0"/>
           </a:p>
         </p:txBody>
@@ -597,10 +374,6 @@
           <a:bodyPr/>
           <a:lstStyle/>
           <a:p>
-            <a:r>
-              <a:rPr lang="en-US" dirty="0"/>
-              <a:t/>
-            </a:r>
             <a:endParaRPr lang="en-US" dirty="0"/>
           </a:p>
         </p:txBody>
@@ -685,10 +458,6 @@
           <a:bodyPr/>
           <a:lstStyle/>
           <a:p>
-            <a:r>
-              <a:rPr lang="en-US" dirty="0"/>
-              <a:t/>
-            </a:r>
             <a:endParaRPr lang="en-US" dirty="0"/>
           </a:p>
         </p:txBody>
@@ -773,10 +542,6 @@
           <a:bodyPr/>
           <a:lstStyle/>
           <a:p>
-            <a:r>
-              <a:rPr lang="en-US" dirty="0"/>
-              <a:t/>
-            </a:r>
             <a:endParaRPr lang="en-US" dirty="0"/>
           </a:p>
         </p:txBody>
@@ -861,10 +626,6 @@
           <a:bodyPr/>
           <a:lstStyle/>
           <a:p>
-            <a:r>
-              <a:rPr lang="en-US" dirty="0"/>
-              <a:t/>
-            </a:r>
             <a:endParaRPr lang="en-US" dirty="0"/>
           </a:p>
         </p:txBody>
@@ -949,10 +710,6 @@
           <a:bodyPr/>
           <a:lstStyle/>
           <a:p>
-            <a:r>
-              <a:rPr lang="en-US" dirty="0"/>
-              <a:t/>
-            </a:r>
             <a:endParaRPr lang="en-US" dirty="0"/>
           </a:p>
         </p:txBody>
@@ -1037,10 +794,6 @@
           <a:bodyPr/>
           <a:lstStyle/>
           <a:p>
-            <a:r>
-              <a:rPr lang="en-US" dirty="0"/>
-              <a:t/>
-            </a:r>
             <a:endParaRPr lang="en-US" dirty="0"/>
           </a:p>
         </p:txBody>
@@ -1125,10 +878,6 @@
           <a:bodyPr/>
           <a:lstStyle/>
           <a:p>
-            <a:r>
-              <a:rPr lang="en-US" dirty="0"/>
-              <a:t/>
-            </a:r>
             <a:endParaRPr lang="en-US" dirty="0"/>
           </a:p>
         </p:txBody>
@@ -1213,10 +962,6 @@
           <a:bodyPr/>
           <a:lstStyle/>
           <a:p>
-            <a:r>
-              <a:rPr lang="en-US" dirty="0"/>
-              <a:t/>
-            </a:r>
             <a:endParaRPr lang="en-US" dirty="0"/>
           </a:p>
         </p:txBody>
@@ -1301,10 +1046,6 @@
           <a:bodyPr/>
           <a:lstStyle/>
           <a:p>
-            <a:r>
-              <a:rPr lang="en-US" dirty="0"/>
-              <a:t/>
-            </a:r>
             <a:endParaRPr lang="en-US" dirty="0"/>
           </a:p>
         </p:txBody>
@@ -1378,6 +1119,11 @@
 <file path=ppt/slideMasters/slideMaster1.xml><?xml version="1.0" encoding="utf-8"?>
 <p:sldMaster xmlns:a="http://schemas.openxmlformats.org/drawingml/2006/main" xmlns:r="http://schemas.openxmlformats.org/officeDocument/2006/relationships" xmlns:p="http://schemas.openxmlformats.org/presentationml/2006/main">
   <p:cSld>
+    <p:bg>
+      <p:bgRef idx="1001">
+        <a:schemeClr val="bg1"/>
+      </p:bgRef>
+    </p:bg>
     <p:spTree>
       <p:nvGrpSpPr>
         <p:cNvPr id="1" name=""/>
@@ -1660,6 +1406,7 @@
         <a:solidFill>
           <a:srgbClr val="1E2761"/>
         </a:solidFill>
+        <a:effectLst/>
       </p:bgPr>
     </p:bg>
     <p:spTree>
@@ -1695,6 +1442,13 @@
           </a:solidFill>
           <a:ln/>
         </p:spPr>
+        <p:txBody>
+          <a:bodyPr/>
+          <a:lstStyle/>
+          <a:p>
+            <a:endParaRPr lang="en-US"/>
+          </a:p>
+        </p:txBody>
       </p:sp>
       <p:sp>
         <p:nvSpPr>
@@ -1715,17 +1469,24 @@
           </a:solidFill>
           <a:ln/>
         </p:spPr>
+        <p:txBody>
+          <a:bodyPr/>
+          <a:lstStyle/>
+          <a:p>
+            <a:endParaRPr lang="en-US"/>
+          </a:p>
+        </p:txBody>
       </p:sp>
       <p:pic>
         <p:nvPicPr>
-          <p:cNvPr id="4" name="Image 0" descr="preencoded.png">    </p:cNvPr>
+          <p:cNvPr id="4" name="Image 0" descr="preencoded.png"/>
           <p:cNvPicPr>
             <a:picLocks noChangeAspect="1"/>
           </p:cNvPicPr>
           <p:nvPr/>
         </p:nvPicPr>
         <p:blipFill>
-          <a:blip r:embed="rId1"/>
+          <a:blip r:embed="rId3"/>
           <a:stretch>
             <a:fillRect/>
           </a:stretch>
@@ -1761,11 +1522,11 @@
           <a:bodyPr wrap="square" rtlCol="0" anchor="ctr"/>
           <a:lstStyle/>
           <a:p>
-            <a:pPr indent="0" marL="0">
-              <a:buNone/>
-            </a:pPr>
-            <a:r>
-              <a:rPr lang="en-US" sz="1400" b="1" spc="200" kern="0" dirty="0">
+            <a:pPr marL="0" indent="0">
+              <a:buNone/>
+            </a:pPr>
+            <a:r>
+              <a:rPr lang="en-US" sz="1400" b="1" kern="0" spc="200" dirty="0">
                 <a:solidFill>
                   <a:srgbClr val="00A896"/>
                 </a:solidFill>
@@ -1800,7 +1561,7 @@
           <a:bodyPr wrap="square" rtlCol="0" anchor="ctr"/>
           <a:lstStyle/>
           <a:p>
-            <a:pPr indent="0" marL="0">
+            <a:pPr marL="0" indent="0">
               <a:lnSpc>
                 <a:spcPts val="4400"/>
               </a:lnSpc>
@@ -1820,7 +1581,7 @@
             <a:endParaRPr lang="en-US" sz="3800" dirty="0"/>
           </a:p>
           <a:p>
-            <a:pPr indent="0" marL="0">
+            <a:pPr marL="0" indent="0">
               <a:lnSpc>
                 <a:spcPts val="4400"/>
               </a:lnSpc>
@@ -1862,7 +1623,7 @@
           <a:bodyPr wrap="square" rtlCol="0" anchor="ctr"/>
           <a:lstStyle/>
           <a:p>
-            <a:pPr indent="0" marL="0">
+            <a:pPr marL="0" indent="0">
               <a:buNone/>
             </a:pPr>
             <a:r>
@@ -1901,7 +1662,7 @@
           <a:bodyPr wrap="square" rtlCol="0" anchor="ctr"/>
           <a:lstStyle/>
           <a:p>
-            <a:pPr indent="0" marL="0">
+            <a:pPr marL="0" indent="0">
               <a:buNone/>
             </a:pPr>
             <a:r>
@@ -1918,7 +1679,7 @@
             <a:endParaRPr lang="en-US" sz="1300" dirty="0"/>
           </a:p>
           <a:p>
-            <a:pPr indent="0" marL="0">
+            <a:pPr marL="0" indent="0">
               <a:buNone/>
             </a:pPr>
             <a:r>
@@ -1952,6 +1713,7 @@
         <a:solidFill>
           <a:srgbClr val="1E2761"/>
         </a:solidFill>
+        <a:effectLst/>
       </p:bgPr>
     </p:bg>
     <p:spTree>
@@ -1987,6 +1749,13 @@
           </a:solidFill>
           <a:ln/>
         </p:spPr>
+        <p:txBody>
+          <a:bodyPr/>
+          <a:lstStyle/>
+          <a:p>
+            <a:endParaRPr lang="en-US"/>
+          </a:p>
+        </p:txBody>
       </p:sp>
       <p:sp>
         <p:nvSpPr>
@@ -2007,17 +1776,24 @@
           </a:solidFill>
           <a:ln/>
         </p:spPr>
+        <p:txBody>
+          <a:bodyPr/>
+          <a:lstStyle/>
+          <a:p>
+            <a:endParaRPr lang="en-US"/>
+          </a:p>
+        </p:txBody>
       </p:sp>
       <p:pic>
         <p:nvPicPr>
-          <p:cNvPr id="4" name="Image 0" descr="preencoded.png">    </p:cNvPr>
+          <p:cNvPr id="4" name="Image 0" descr="preencoded.png"/>
           <p:cNvPicPr>
             <a:picLocks noChangeAspect="1"/>
           </p:cNvPicPr>
           <p:nvPr/>
         </p:nvPicPr>
         <p:blipFill>
-          <a:blip r:embed="rId1"/>
+          <a:blip r:embed="rId3"/>
           <a:stretch>
             <a:fillRect/>
           </a:stretch>
@@ -2053,7 +1829,7 @@
           <a:bodyPr wrap="square" rtlCol="0" anchor="ctr"/>
           <a:lstStyle/>
           <a:p>
-            <a:pPr indent="0" marL="0">
+            <a:pPr marL="0" indent="0">
               <a:buNone/>
             </a:pPr>
             <a:r>
@@ -2092,7 +1868,7 @@
           <a:bodyPr wrap="square" rtlCol="0" anchor="ctr"/>
           <a:lstStyle/>
           <a:p>
-            <a:pPr indent="0" marL="0">
+            <a:pPr marL="0" indent="0">
               <a:buNone/>
             </a:pPr>
             <a:r>
@@ -2112,14 +1888,14 @@
       </p:sp>
       <p:pic>
         <p:nvPicPr>
-          <p:cNvPr id="7" name="Image 1" descr="preencoded.png">    </p:cNvPr>
+          <p:cNvPr id="7" name="Image 1" descr="preencoded.png"/>
           <p:cNvPicPr>
             <a:picLocks noChangeAspect="1"/>
           </p:cNvPicPr>
           <p:nvPr/>
         </p:nvPicPr>
         <p:blipFill>
-          <a:blip r:embed="rId2"/>
+          <a:blip r:embed="rId4"/>
           <a:stretch>
             <a:fillRect/>
           </a:stretch>
@@ -2155,7 +1931,7 @@
           <a:bodyPr wrap="square" rtlCol="0" anchor="ctr"/>
           <a:lstStyle/>
           <a:p>
-            <a:pPr indent="0" marL="0">
+            <a:pPr marL="0" indent="0">
               <a:buNone/>
             </a:pPr>
             <a:r>
@@ -2194,7 +1970,7 @@
           <a:bodyPr wrap="square" rtlCol="0" anchor="ctr"/>
           <a:lstStyle/>
           <a:p>
-            <a:pPr indent="0" marL="0">
+            <a:pPr marL="0" indent="0">
               <a:buNone/>
             </a:pPr>
             <a:r>
@@ -2228,6 +2004,7 @@
         <a:solidFill>
           <a:srgbClr val="FFFFFF"/>
         </a:solidFill>
+        <a:effectLst/>
       </p:bgPr>
     </p:bg>
     <p:spTree>
@@ -2265,7 +2042,7 @@
           <a:bodyPr wrap="square" rtlCol="0" anchor="ctr"/>
           <a:lstStyle/>
           <a:p>
-            <a:pPr indent="0" marL="0">
+            <a:pPr marL="0" indent="0">
               <a:buNone/>
             </a:pPr>
             <a:r>
@@ -2304,7 +2081,7 @@
           <a:bodyPr wrap="square" rtlCol="0" anchor="ctr"/>
           <a:lstStyle/>
           <a:p>
-            <a:pPr indent="0" marL="0">
+            <a:pPr marL="0" indent="0">
               <a:lnSpc>
                 <a:spcPct val="125000"/>
               </a:lnSpc>
@@ -2346,13 +2123,20 @@
           </a:solidFill>
           <a:ln/>
           <a:effectLst>
-            <a:outerShdw sx="100000" sy="100000" kx="0" ky="0" algn="bl" rotWithShape="0" blurRad="101600" dist="38100" dir="5400000">
+            <a:outerShdw blurRad="101600" dist="38100" dir="5400000" algn="bl" rotWithShape="0">
               <a:srgbClr val="1E2761">
                 <a:alpha val="10000"/>
               </a:srgbClr>
             </a:outerShdw>
           </a:effectLst>
         </p:spPr>
+        <p:txBody>
+          <a:bodyPr/>
+          <a:lstStyle/>
+          <a:p>
+            <a:endParaRPr lang="en-US"/>
+          </a:p>
+        </p:txBody>
       </p:sp>
       <p:sp>
         <p:nvSpPr>
@@ -2373,318 +2157,17 @@
           </a:solidFill>
           <a:ln/>
         </p:spPr>
+        <p:txBody>
+          <a:bodyPr/>
+          <a:lstStyle/>
+          <a:p>
+            <a:endParaRPr lang="en-US"/>
+          </a:p>
+        </p:txBody>
       </p:sp>
       <p:pic>
         <p:nvPicPr>
-          <p:cNvPr id="6" name="Image 0" descr="preencoded.png">    </p:cNvPr>
-          <p:cNvPicPr>
-            <a:picLocks noChangeAspect="1"/>
-          </p:cNvPicPr>
-          <p:nvPr/>
-        </p:nvPicPr>
-        <p:blipFill>
-          <a:blip r:embed="rId1"/>
-          <a:stretch>
-            <a:fillRect/>
-          </a:stretch>
-        </p:blipFill>
-        <p:spPr>
-          <a:xfrm>
-            <a:off x="969264" y="3163824"/>
-            <a:ext cx="347472" cy="347472"/>
-          </a:xfrm>
-          <a:prstGeom prst="rect">
-            <a:avLst/>
-          </a:prstGeom>
-        </p:spPr>
-      </p:pic>
-      <p:sp>
-        <p:nvSpPr>
-          <p:cNvPr id="7" name="Text 4"/>
-          <p:cNvSpPr/>
-          <p:nvPr/>
-        </p:nvSpPr>
-        <p:spPr>
-          <a:xfrm>
-            <a:off x="822960" y="3840480"/>
-            <a:ext cx="2834640" cy="411480"/>
-          </a:xfrm>
-          <a:prstGeom prst="rect">
-            <a:avLst/>
-          </a:prstGeom>
-          <a:noFill/>
-          <a:ln/>
-        </p:spPr>
-        <p:txBody>
-          <a:bodyPr wrap="square" rtlCol="0" anchor="ctr"/>
-          <a:lstStyle/>
-          <a:p>
-            <a:pPr indent="0" marL="0">
-              <a:buNone/>
-            </a:pPr>
-            <a:r>
-              <a:rPr lang="en-US" sz="1600" b="1" dirty="0">
-                <a:solidFill>
-                  <a:srgbClr val="1E2761"/>
-                </a:solidFill>
-                <a:latin typeface="Calibri" pitchFamily="34" charset="0"/>
-                <a:ea typeface="Calibri" pitchFamily="34" charset="-122"/>
-                <a:cs typeface="Calibri" pitchFamily="34" charset="-120"/>
-              </a:rPr>
-              <a:t>Anomaly Detection</a:t>
-            </a:r>
-            <a:endParaRPr lang="en-US" sz="1600" dirty="0"/>
-          </a:p>
-        </p:txBody>
-      </p:sp>
-      <p:sp>
-        <p:nvSpPr>
-          <p:cNvPr id="8" name="Text 5"/>
-          <p:cNvSpPr/>
-          <p:nvPr/>
-        </p:nvSpPr>
-        <p:spPr>
-          <a:xfrm>
-            <a:off x="822960" y="4279392"/>
-            <a:ext cx="2834640" cy="1371600"/>
-          </a:xfrm>
-          <a:prstGeom prst="rect">
-            <a:avLst/>
-          </a:prstGeom>
-          <a:noFill/>
-          <a:ln/>
-        </p:spPr>
-        <p:txBody>
-          <a:bodyPr wrap="square" rtlCol="0" anchor="ctr"/>
-          <a:lstStyle/>
-          <a:p>
-            <a:pPr indent="0" marL="0">
-              <a:lnSpc>
-                <a:spcPct val="120000"/>
-              </a:lnSpc>
-              <a:buNone/>
-            </a:pPr>
-            <a:r>
-              <a:rPr lang="en-US" sz="1250" dirty="0">
-                <a:solidFill>
-                  <a:srgbClr val="5B6B8C"/>
-                </a:solidFill>
-                <a:latin typeface="Calibri" pitchFamily="34" charset="0"/>
-                <a:ea typeface="Calibri" pitchFamily="34" charset="-122"/>
-                <a:cs typeface="Calibri" pitchFamily="34" charset="-120"/>
-              </a:rPr>
-              <a:t>Flag claims that deviate from a provider’s normal billing pattern over time.</a:t>
-            </a:r>
-            <a:endParaRPr lang="en-US" sz="1250" dirty="0"/>
-          </a:p>
-        </p:txBody>
-      </p:sp>
-      <p:sp>
-        <p:nvSpPr>
-          <p:cNvPr id="9" name="Shape 6"/>
-          <p:cNvSpPr/>
-          <p:nvPr/>
-        </p:nvSpPr>
-        <p:spPr>
-          <a:xfrm>
-            <a:off x="4251960" y="2743200"/>
-            <a:ext cx="3383280" cy="3017520"/>
-          </a:xfrm>
-          <a:prstGeom prst="roundRect">
-            <a:avLst>
-              <a:gd name="adj" fmla="val 2424"/>
-            </a:avLst>
-          </a:prstGeom>
-          <a:solidFill>
-            <a:srgbClr val="F4F7FC"/>
-          </a:solidFill>
-          <a:ln/>
-          <a:effectLst>
-            <a:outerShdw sx="100000" sy="100000" kx="0" ky="0" algn="bl" rotWithShape="0" blurRad="101600" dist="38100" dir="5400000">
-              <a:srgbClr val="1E2761">
-                <a:alpha val="10000"/>
-              </a:srgbClr>
-            </a:outerShdw>
-          </a:effectLst>
-        </p:spPr>
-      </p:sp>
-      <p:sp>
-        <p:nvSpPr>
-          <p:cNvPr id="10" name="Shape 7"/>
-          <p:cNvSpPr/>
-          <p:nvPr/>
-        </p:nvSpPr>
-        <p:spPr>
-          <a:xfrm>
-            <a:off x="4526280" y="3017520"/>
-            <a:ext cx="640080" cy="640080"/>
-          </a:xfrm>
-          <a:prstGeom prst="ellipse">
-            <a:avLst/>
-          </a:prstGeom>
-          <a:solidFill>
-            <a:srgbClr val="1E2761"/>
-          </a:solidFill>
-          <a:ln/>
-        </p:spPr>
-      </p:sp>
-      <p:pic>
-        <p:nvPicPr>
-          <p:cNvPr id="11" name="Image 1" descr="preencoded.png">    </p:cNvPr>
-          <p:cNvPicPr>
-            <a:picLocks noChangeAspect="1"/>
-          </p:cNvPicPr>
-          <p:nvPr/>
-        </p:nvPicPr>
-        <p:blipFill>
-          <a:blip r:embed="rId2"/>
-          <a:stretch>
-            <a:fillRect/>
-          </a:stretch>
-        </p:blipFill>
-        <p:spPr>
-          <a:xfrm>
-            <a:off x="4672584" y="3163824"/>
-            <a:ext cx="347472" cy="347472"/>
-          </a:xfrm>
-          <a:prstGeom prst="rect">
-            <a:avLst/>
-          </a:prstGeom>
-        </p:spPr>
-      </p:pic>
-      <p:sp>
-        <p:nvSpPr>
-          <p:cNvPr id="12" name="Text 8"/>
-          <p:cNvSpPr/>
-          <p:nvPr/>
-        </p:nvSpPr>
-        <p:spPr>
-          <a:xfrm>
-            <a:off x="4526280" y="3840480"/>
-            <a:ext cx="2834640" cy="411480"/>
-          </a:xfrm>
-          <a:prstGeom prst="rect">
-            <a:avLst/>
-          </a:prstGeom>
-          <a:noFill/>
-          <a:ln/>
-        </p:spPr>
-        <p:txBody>
-          <a:bodyPr wrap="square" rtlCol="0" anchor="ctr"/>
-          <a:lstStyle/>
-          <a:p>
-            <a:pPr indent="0" marL="0">
-              <a:buNone/>
-            </a:pPr>
-            <a:r>
-              <a:rPr lang="en-US" sz="1600" b="1" dirty="0">
-                <a:solidFill>
-                  <a:srgbClr val="1E2761"/>
-                </a:solidFill>
-                <a:latin typeface="Calibri" pitchFamily="34" charset="0"/>
-                <a:ea typeface="Calibri" pitchFamily="34" charset="-122"/>
-                <a:cs typeface="Calibri" pitchFamily="34" charset="-120"/>
-              </a:rPr>
-              <a:t>Classification</a:t>
-            </a:r>
-            <a:endParaRPr lang="en-US" sz="1600" dirty="0"/>
-          </a:p>
-        </p:txBody>
-      </p:sp>
-      <p:sp>
-        <p:nvSpPr>
-          <p:cNvPr id="13" name="Text 9"/>
-          <p:cNvSpPr/>
-          <p:nvPr/>
-        </p:nvSpPr>
-        <p:spPr>
-          <a:xfrm>
-            <a:off x="4526280" y="4279392"/>
-            <a:ext cx="2834640" cy="1371600"/>
-          </a:xfrm>
-          <a:prstGeom prst="rect">
-            <a:avLst/>
-          </a:prstGeom>
-          <a:noFill/>
-          <a:ln/>
-        </p:spPr>
-        <p:txBody>
-          <a:bodyPr wrap="square" rtlCol="0" anchor="ctr"/>
-          <a:lstStyle/>
-          <a:p>
-            <a:pPr indent="0" marL="0">
-              <a:lnSpc>
-                <a:spcPct val="120000"/>
-              </a:lnSpc>
-              <a:buNone/>
-            </a:pPr>
-            <a:r>
-              <a:rPr lang="en-US" sz="1250" dirty="0">
-                <a:solidFill>
-                  <a:srgbClr val="5B6B8C"/>
-                </a:solidFill>
-                <a:latin typeface="Calibri" pitchFamily="34" charset="0"/>
-                <a:ea typeface="Calibri" pitchFamily="34" charset="-122"/>
-                <a:cs typeface="Calibri" pitchFamily="34" charset="-120"/>
-              </a:rPr>
-              <a:t>Triage why a claim was flagged — upcoding, unbundling, duplicate billing.</a:t>
-            </a:r>
-            <a:endParaRPr lang="en-US" sz="1250" dirty="0"/>
-          </a:p>
-        </p:txBody>
-      </p:sp>
-      <p:sp>
-        <p:nvSpPr>
-          <p:cNvPr id="14" name="Shape 10"/>
-          <p:cNvSpPr/>
-          <p:nvPr/>
-        </p:nvSpPr>
-        <p:spPr>
-          <a:xfrm>
-            <a:off x="7955280" y="2743200"/>
-            <a:ext cx="3383280" cy="3017520"/>
-          </a:xfrm>
-          <a:prstGeom prst="roundRect">
-            <a:avLst>
-              <a:gd name="adj" fmla="val 2424"/>
-            </a:avLst>
-          </a:prstGeom>
-          <a:solidFill>
-            <a:srgbClr val="F4F7FC"/>
-          </a:solidFill>
-          <a:ln/>
-          <a:effectLst>
-            <a:outerShdw sx="100000" sy="100000" kx="0" ky="0" algn="bl" rotWithShape="0" blurRad="101600" dist="38100" dir="5400000">
-              <a:srgbClr val="1E2761">
-                <a:alpha val="10000"/>
-              </a:srgbClr>
-            </a:outerShdw>
-          </a:effectLst>
-        </p:spPr>
-      </p:sp>
-      <p:sp>
-        <p:nvSpPr>
-          <p:cNvPr id="15" name="Shape 11"/>
-          <p:cNvSpPr/>
-          <p:nvPr/>
-        </p:nvSpPr>
-        <p:spPr>
-          <a:xfrm>
-            <a:off x="8229600" y="3017520"/>
-            <a:ext cx="640080" cy="640080"/>
-          </a:xfrm>
-          <a:prstGeom prst="ellipse">
-            <a:avLst/>
-          </a:prstGeom>
-          <a:solidFill>
-            <a:srgbClr val="1E2761"/>
-          </a:solidFill>
-          <a:ln/>
-        </p:spPr>
-      </p:sp>
-      <p:pic>
-        <p:nvPicPr>
-          <p:cNvPr id="16" name="Image 2" descr="preencoded.png">    </p:cNvPr>
+          <p:cNvPr id="6" name="Image 0" descr="preencoded.png"/>
           <p:cNvPicPr>
             <a:picLocks noChangeAspect="1"/>
           </p:cNvPicPr>
@@ -2698,7 +2181,7 @@
         </p:blipFill>
         <p:spPr>
           <a:xfrm>
-            <a:off x="8375904" y="3163824"/>
+            <a:off x="969264" y="3163824"/>
             <a:ext cx="347472" cy="347472"/>
           </a:xfrm>
           <a:prstGeom prst="rect">
@@ -2708,13 +2191,13 @@
       </p:pic>
       <p:sp>
         <p:nvSpPr>
-          <p:cNvPr id="17" name="Text 12"/>
-          <p:cNvSpPr/>
-          <p:nvPr/>
-        </p:nvSpPr>
-        <p:spPr>
-          <a:xfrm>
-            <a:off x="8229600" y="3840480"/>
+          <p:cNvPr id="7" name="Text 4"/>
+          <p:cNvSpPr/>
+          <p:nvPr/>
+        </p:nvSpPr>
+        <p:spPr>
+          <a:xfrm>
+            <a:off x="822960" y="3840480"/>
             <a:ext cx="2834640" cy="411480"/>
           </a:xfrm>
           <a:prstGeom prst="rect">
@@ -2727,7 +2210,7 @@
           <a:bodyPr wrap="square" rtlCol="0" anchor="ctr"/>
           <a:lstStyle/>
           <a:p>
-            <a:pPr indent="0" marL="0">
+            <a:pPr marL="0" indent="0">
               <a:buNone/>
             </a:pPr>
             <a:r>
@@ -2739,6 +2222,341 @@
                 <a:ea typeface="Calibri" pitchFamily="34" charset="-122"/>
                 <a:cs typeface="Calibri" pitchFamily="34" charset="-120"/>
               </a:rPr>
+              <a:t>Anomaly Detection</a:t>
+            </a:r>
+            <a:endParaRPr lang="en-US" sz="1600" dirty="0"/>
+          </a:p>
+        </p:txBody>
+      </p:sp>
+      <p:sp>
+        <p:nvSpPr>
+          <p:cNvPr id="8" name="Text 5"/>
+          <p:cNvSpPr/>
+          <p:nvPr/>
+        </p:nvSpPr>
+        <p:spPr>
+          <a:xfrm>
+            <a:off x="822960" y="4279392"/>
+            <a:ext cx="2834640" cy="1371600"/>
+          </a:xfrm>
+          <a:prstGeom prst="rect">
+            <a:avLst/>
+          </a:prstGeom>
+          <a:noFill/>
+          <a:ln/>
+        </p:spPr>
+        <p:txBody>
+          <a:bodyPr wrap="square" rtlCol="0" anchor="ctr"/>
+          <a:lstStyle/>
+          <a:p>
+            <a:pPr marL="0" indent="0">
+              <a:lnSpc>
+                <a:spcPct val="120000"/>
+              </a:lnSpc>
+              <a:buNone/>
+            </a:pPr>
+            <a:r>
+              <a:rPr lang="en-US" sz="1250">
+                <a:solidFill>
+                  <a:srgbClr val="5B6B8C"/>
+                </a:solidFill>
+                <a:latin typeface="Calibri" pitchFamily="34" charset="0"/>
+                <a:ea typeface="Calibri" pitchFamily="34" charset="-122"/>
+                <a:cs typeface="Calibri" pitchFamily="34" charset="-120"/>
+              </a:rPr>
+              <a:t>Flag claims priced well outside the peer norm for that procedure over time</a:t>
+            </a:r>
+          </a:p>
+        </p:txBody>
+      </p:sp>
+      <p:sp>
+        <p:nvSpPr>
+          <p:cNvPr id="9" name="Shape 6"/>
+          <p:cNvSpPr/>
+          <p:nvPr/>
+        </p:nvSpPr>
+        <p:spPr>
+          <a:xfrm>
+            <a:off x="4251960" y="2743200"/>
+            <a:ext cx="3383280" cy="3017520"/>
+          </a:xfrm>
+          <a:prstGeom prst="roundRect">
+            <a:avLst>
+              <a:gd name="adj" fmla="val 2424"/>
+            </a:avLst>
+          </a:prstGeom>
+          <a:solidFill>
+            <a:srgbClr val="F4F7FC"/>
+          </a:solidFill>
+          <a:ln/>
+          <a:effectLst>
+            <a:outerShdw blurRad="101600" dist="38100" dir="5400000" algn="bl" rotWithShape="0">
+              <a:srgbClr val="1E2761">
+                <a:alpha val="10000"/>
+              </a:srgbClr>
+            </a:outerShdw>
+          </a:effectLst>
+        </p:spPr>
+        <p:txBody>
+          <a:bodyPr/>
+          <a:lstStyle/>
+          <a:p>
+            <a:endParaRPr lang="en-US"/>
+          </a:p>
+        </p:txBody>
+      </p:sp>
+      <p:sp>
+        <p:nvSpPr>
+          <p:cNvPr id="10" name="Shape 7"/>
+          <p:cNvSpPr/>
+          <p:nvPr/>
+        </p:nvSpPr>
+        <p:spPr>
+          <a:xfrm>
+            <a:off x="4526280" y="3017520"/>
+            <a:ext cx="640080" cy="640080"/>
+          </a:xfrm>
+          <a:prstGeom prst="ellipse">
+            <a:avLst/>
+          </a:prstGeom>
+          <a:solidFill>
+            <a:srgbClr val="1E2761"/>
+          </a:solidFill>
+          <a:ln/>
+        </p:spPr>
+        <p:txBody>
+          <a:bodyPr/>
+          <a:lstStyle/>
+          <a:p>
+            <a:endParaRPr lang="en-US"/>
+          </a:p>
+        </p:txBody>
+      </p:sp>
+      <p:pic>
+        <p:nvPicPr>
+          <p:cNvPr id="11" name="Image 1" descr="preencoded.png"/>
+          <p:cNvPicPr>
+            <a:picLocks noChangeAspect="1"/>
+          </p:cNvPicPr>
+          <p:nvPr/>
+        </p:nvPicPr>
+        <p:blipFill>
+          <a:blip r:embed="rId4"/>
+          <a:stretch>
+            <a:fillRect/>
+          </a:stretch>
+        </p:blipFill>
+        <p:spPr>
+          <a:xfrm>
+            <a:off x="4672584" y="3163824"/>
+            <a:ext cx="347472" cy="347472"/>
+          </a:xfrm>
+          <a:prstGeom prst="rect">
+            <a:avLst/>
+          </a:prstGeom>
+        </p:spPr>
+      </p:pic>
+      <p:sp>
+        <p:nvSpPr>
+          <p:cNvPr id="12" name="Text 8"/>
+          <p:cNvSpPr/>
+          <p:nvPr/>
+        </p:nvSpPr>
+        <p:spPr>
+          <a:xfrm>
+            <a:off x="4526280" y="3840480"/>
+            <a:ext cx="2834640" cy="411480"/>
+          </a:xfrm>
+          <a:prstGeom prst="rect">
+            <a:avLst/>
+          </a:prstGeom>
+          <a:noFill/>
+          <a:ln/>
+        </p:spPr>
+        <p:txBody>
+          <a:bodyPr wrap="square" rtlCol="0" anchor="ctr"/>
+          <a:lstStyle/>
+          <a:p>
+            <a:pPr marL="0" indent="0">
+              <a:buNone/>
+            </a:pPr>
+            <a:r>
+              <a:rPr lang="en-US" sz="1600" b="1" dirty="0">
+                <a:solidFill>
+                  <a:srgbClr val="1E2761"/>
+                </a:solidFill>
+                <a:latin typeface="Calibri" pitchFamily="34" charset="0"/>
+                <a:ea typeface="Calibri" pitchFamily="34" charset="-122"/>
+                <a:cs typeface="Calibri" pitchFamily="34" charset="-120"/>
+              </a:rPr>
+              <a:t>Classification</a:t>
+            </a:r>
+            <a:endParaRPr lang="en-US" sz="1600" dirty="0"/>
+          </a:p>
+        </p:txBody>
+      </p:sp>
+      <p:sp>
+        <p:nvSpPr>
+          <p:cNvPr id="13" name="Text 9"/>
+          <p:cNvSpPr/>
+          <p:nvPr/>
+        </p:nvSpPr>
+        <p:spPr>
+          <a:xfrm>
+            <a:off x="4526280" y="4279392"/>
+            <a:ext cx="2834640" cy="1371600"/>
+          </a:xfrm>
+          <a:prstGeom prst="rect">
+            <a:avLst/>
+          </a:prstGeom>
+          <a:noFill/>
+          <a:ln/>
+        </p:spPr>
+        <p:txBody>
+          <a:bodyPr wrap="square" rtlCol="0" anchor="ctr"/>
+          <a:lstStyle/>
+          <a:p>
+            <a:pPr marL="0" indent="0">
+              <a:lnSpc>
+                <a:spcPct val="120000"/>
+              </a:lnSpc>
+              <a:buNone/>
+            </a:pPr>
+            <a:r>
+              <a:rPr lang="en-US" sz="1250" dirty="0">
+                <a:solidFill>
+                  <a:srgbClr val="5B6B8C"/>
+                </a:solidFill>
+                <a:latin typeface="Calibri" pitchFamily="34" charset="0"/>
+                <a:ea typeface="Calibri" pitchFamily="34" charset="-122"/>
+                <a:cs typeface="Calibri" pitchFamily="34" charset="-120"/>
+              </a:rPr>
+              <a:t>Triage why a claim was flagged — upcoding, unbundling, duplicate billing.</a:t>
+            </a:r>
+            <a:endParaRPr lang="en-US" sz="1250" dirty="0"/>
+          </a:p>
+        </p:txBody>
+      </p:sp>
+      <p:sp>
+        <p:nvSpPr>
+          <p:cNvPr id="14" name="Shape 10"/>
+          <p:cNvSpPr/>
+          <p:nvPr/>
+        </p:nvSpPr>
+        <p:spPr>
+          <a:xfrm>
+            <a:off x="7955280" y="2743200"/>
+            <a:ext cx="3383280" cy="3017520"/>
+          </a:xfrm>
+          <a:prstGeom prst="roundRect">
+            <a:avLst>
+              <a:gd name="adj" fmla="val 2424"/>
+            </a:avLst>
+          </a:prstGeom>
+          <a:solidFill>
+            <a:srgbClr val="F4F7FC"/>
+          </a:solidFill>
+          <a:ln/>
+          <a:effectLst>
+            <a:outerShdw blurRad="101600" dist="38100" dir="5400000" algn="bl" rotWithShape="0">
+              <a:srgbClr val="1E2761">
+                <a:alpha val="10000"/>
+              </a:srgbClr>
+            </a:outerShdw>
+          </a:effectLst>
+        </p:spPr>
+        <p:txBody>
+          <a:bodyPr/>
+          <a:lstStyle/>
+          <a:p>
+            <a:endParaRPr lang="en-US"/>
+          </a:p>
+        </p:txBody>
+      </p:sp>
+      <p:sp>
+        <p:nvSpPr>
+          <p:cNvPr id="15" name="Shape 11"/>
+          <p:cNvSpPr/>
+          <p:nvPr/>
+        </p:nvSpPr>
+        <p:spPr>
+          <a:xfrm>
+            <a:off x="8229600" y="3017520"/>
+            <a:ext cx="640080" cy="640080"/>
+          </a:xfrm>
+          <a:prstGeom prst="ellipse">
+            <a:avLst/>
+          </a:prstGeom>
+          <a:solidFill>
+            <a:srgbClr val="1E2761"/>
+          </a:solidFill>
+          <a:ln/>
+        </p:spPr>
+        <p:txBody>
+          <a:bodyPr/>
+          <a:lstStyle/>
+          <a:p>
+            <a:endParaRPr lang="en-US"/>
+          </a:p>
+        </p:txBody>
+      </p:sp>
+      <p:pic>
+        <p:nvPicPr>
+          <p:cNvPr id="16" name="Image 2" descr="preencoded.png"/>
+          <p:cNvPicPr>
+            <a:picLocks noChangeAspect="1"/>
+          </p:cNvPicPr>
+          <p:nvPr/>
+        </p:nvPicPr>
+        <p:blipFill>
+          <a:blip r:embed="rId5"/>
+          <a:stretch>
+            <a:fillRect/>
+          </a:stretch>
+        </p:blipFill>
+        <p:spPr>
+          <a:xfrm>
+            <a:off x="8375904" y="3163824"/>
+            <a:ext cx="347472" cy="347472"/>
+          </a:xfrm>
+          <a:prstGeom prst="rect">
+            <a:avLst/>
+          </a:prstGeom>
+        </p:spPr>
+      </p:pic>
+      <p:sp>
+        <p:nvSpPr>
+          <p:cNvPr id="17" name="Text 12"/>
+          <p:cNvSpPr/>
+          <p:nvPr/>
+        </p:nvSpPr>
+        <p:spPr>
+          <a:xfrm>
+            <a:off x="8229600" y="3840480"/>
+            <a:ext cx="2834640" cy="411480"/>
+          </a:xfrm>
+          <a:prstGeom prst="rect">
+            <a:avLst/>
+          </a:prstGeom>
+          <a:noFill/>
+          <a:ln/>
+        </p:spPr>
+        <p:txBody>
+          <a:bodyPr wrap="square" rtlCol="0" anchor="ctr"/>
+          <a:lstStyle/>
+          <a:p>
+            <a:pPr marL="0" indent="0">
+              <a:buNone/>
+            </a:pPr>
+            <a:r>
+              <a:rPr lang="en-US" sz="1600" b="1" dirty="0">
+                <a:solidFill>
+                  <a:srgbClr val="1E2761"/>
+                </a:solidFill>
+                <a:latin typeface="Calibri" pitchFamily="34" charset="0"/>
+                <a:ea typeface="Calibri" pitchFamily="34" charset="-122"/>
+                <a:cs typeface="Calibri" pitchFamily="34" charset="-120"/>
+              </a:rPr>
               <a:t>Chain Reasoning</a:t>
             </a:r>
             <a:endParaRPr lang="en-US" sz="1600" dirty="0"/>
@@ -2766,7 +2584,7 @@
           <a:bodyPr wrap="square" rtlCol="0" anchor="ctr"/>
           <a:lstStyle/>
           <a:p>
-            <a:pPr indent="0" marL="0">
+            <a:pPr marL="0" indent="0">
               <a:lnSpc>
                 <a:spcPct val="120000"/>
               </a:lnSpc>
@@ -2803,6 +2621,7 @@
         <a:solidFill>
           <a:srgbClr val="FFFFFF"/>
         </a:solidFill>
+        <a:effectLst/>
       </p:bgPr>
     </p:bg>
     <p:spTree>
@@ -2840,7 +2659,7 @@
           <a:bodyPr wrap="square" rtlCol="0" anchor="ctr"/>
           <a:lstStyle/>
           <a:p>
-            <a:pPr indent="0" marL="0">
+            <a:pPr marL="0" indent="0">
               <a:buNone/>
             </a:pPr>
             <a:r>
@@ -2882,17 +2701,24 @@
             <a:prstDash val="solid"/>
           </a:ln>
         </p:spPr>
+        <p:txBody>
+          <a:bodyPr/>
+          <a:lstStyle/>
+          <a:p>
+            <a:endParaRPr lang="en-US"/>
+          </a:p>
+        </p:txBody>
       </p:sp>
       <p:pic>
         <p:nvPicPr>
-          <p:cNvPr id="4" name="Image 0" descr="preencoded.png">    </p:cNvPr>
+          <p:cNvPr id="4" name="Image 0" descr="preencoded.png"/>
           <p:cNvPicPr>
             <a:picLocks noChangeAspect="1"/>
           </p:cNvPicPr>
           <p:nvPr/>
         </p:nvPicPr>
         <p:blipFill>
-          <a:blip r:embed="rId1"/>
+          <a:blip r:embed="rId3"/>
           <a:stretch>
             <a:fillRect/>
           </a:stretch>
@@ -2928,7 +2754,7 @@
           <a:bodyPr wrap="square" rtlCol="0" anchor="ctr"/>
           <a:lstStyle/>
           <a:p>
-            <a:pPr indent="0" marL="0">
+            <a:pPr marL="0" indent="0">
               <a:buNone/>
             </a:pPr>
             <a:r>
@@ -2967,7 +2793,7 @@
           <a:bodyPr wrap="square" rtlCol="0" anchor="ctr"/>
           <a:lstStyle/>
           <a:p>
-            <a:pPr indent="0" marL="0">
+            <a:pPr marL="0" indent="0">
               <a:lnSpc>
                 <a:spcPct val="120000"/>
               </a:lnSpc>
@@ -3012,17 +2838,24 @@
             <a:prstDash val="solid"/>
           </a:ln>
         </p:spPr>
+        <p:txBody>
+          <a:bodyPr/>
+          <a:lstStyle/>
+          <a:p>
+            <a:endParaRPr lang="en-US"/>
+          </a:p>
+        </p:txBody>
       </p:sp>
       <p:pic>
         <p:nvPicPr>
-          <p:cNvPr id="8" name="Image 1" descr="preencoded.png">    </p:cNvPr>
+          <p:cNvPr id="8" name="Image 1" descr="preencoded.png"/>
           <p:cNvPicPr>
             <a:picLocks noChangeAspect="1"/>
           </p:cNvPicPr>
           <p:nvPr/>
         </p:nvPicPr>
         <p:blipFill>
-          <a:blip r:embed="rId2"/>
+          <a:blip r:embed="rId4"/>
           <a:stretch>
             <a:fillRect/>
           </a:stretch>
@@ -3058,7 +2891,7 @@
           <a:bodyPr wrap="square" rtlCol="0" anchor="ctr"/>
           <a:lstStyle/>
           <a:p>
-            <a:pPr indent="0" marL="0">
+            <a:pPr marL="0" indent="0">
               <a:buNone/>
             </a:pPr>
             <a:r>
@@ -3097,7 +2930,7 @@
           <a:bodyPr wrap="square" rtlCol="0" anchor="ctr"/>
           <a:lstStyle/>
           <a:p>
-            <a:pPr indent="0" marL="0">
+            <a:pPr marL="0" indent="0">
               <a:lnSpc>
                 <a:spcPct val="120000"/>
               </a:lnSpc>
@@ -3142,17 +2975,24 @@
             <a:prstDash val="solid"/>
           </a:ln>
         </p:spPr>
+        <p:txBody>
+          <a:bodyPr/>
+          <a:lstStyle/>
+          <a:p>
+            <a:endParaRPr lang="en-US"/>
+          </a:p>
+        </p:txBody>
       </p:sp>
       <p:pic>
         <p:nvPicPr>
-          <p:cNvPr id="12" name="Image 2" descr="preencoded.png">    </p:cNvPr>
+          <p:cNvPr id="12" name="Image 2" descr="preencoded.png"/>
           <p:cNvPicPr>
             <a:picLocks noChangeAspect="1"/>
           </p:cNvPicPr>
           <p:nvPr/>
         </p:nvPicPr>
         <p:blipFill>
-          <a:blip r:embed="rId3"/>
+          <a:blip r:embed="rId5"/>
           <a:stretch>
             <a:fillRect/>
           </a:stretch>
@@ -3188,7 +3028,7 @@
           <a:bodyPr wrap="square" rtlCol="0" anchor="ctr"/>
           <a:lstStyle/>
           <a:p>
-            <a:pPr indent="0" marL="0">
+            <a:pPr marL="0" indent="0">
               <a:buNone/>
             </a:pPr>
             <a:r>
@@ -3227,7 +3067,7 @@
           <a:bodyPr wrap="square" rtlCol="0" anchor="ctr"/>
           <a:lstStyle/>
           <a:p>
-            <a:pPr indent="0" marL="0">
+            <a:pPr marL="0" indent="0">
               <a:lnSpc>
                 <a:spcPct val="120000"/>
               </a:lnSpc>
@@ -3269,7 +3109,7 @@
           <a:bodyPr wrap="square" rtlCol="0" anchor="ctr"/>
           <a:lstStyle/>
           <a:p>
-            <a:pPr indent="0" marL="0">
+            <a:pPr marL="0" indent="0">
               <a:buNone/>
             </a:pPr>
             <a:r>
@@ -3303,6 +3143,7 @@
         <a:solidFill>
           <a:srgbClr val="FFFFFF"/>
         </a:solidFill>
+        <a:effectLst/>
       </p:bgPr>
     </p:bg>
     <p:spTree>
@@ -3340,7 +3181,7 @@
           <a:bodyPr wrap="square" rtlCol="0" anchor="ctr"/>
           <a:lstStyle/>
           <a:p>
-            <a:pPr indent="0" marL="0">
+            <a:pPr marL="0" indent="0">
               <a:buNone/>
             </a:pPr>
             <a:r>
@@ -3379,6 +3220,13 @@
           </a:solidFill>
           <a:ln/>
         </p:spPr>
+        <p:txBody>
+          <a:bodyPr/>
+          <a:lstStyle/>
+          <a:p>
+            <a:endParaRPr lang="en-US"/>
+          </a:p>
+        </p:txBody>
       </p:sp>
       <p:sp>
         <p:nvSpPr>
@@ -3401,7 +3249,7 @@
           <a:bodyPr wrap="square" rtlCol="0" anchor="ctr"/>
           <a:lstStyle/>
           <a:p>
-            <a:pPr algn="ctr" indent="0" marL="0">
+            <a:pPr marL="0" indent="0" algn="ctr">
               <a:buNone/>
             </a:pPr>
             <a:r>
@@ -3440,7 +3288,7 @@
           <a:bodyPr wrap="square" rtlCol="0" anchor="ctr"/>
           <a:lstStyle/>
           <a:p>
-            <a:pPr algn="ctr" indent="0" marL="0">
+            <a:pPr marL="0" indent="0" algn="ctr">
               <a:lnSpc>
                 <a:spcPct val="125000"/>
               </a:lnSpc>
@@ -3483,6 +3331,13 @@
             <a:prstDash val="solid"/>
           </a:ln>
         </p:spPr>
+        <p:txBody>
+          <a:bodyPr/>
+          <a:lstStyle/>
+          <a:p>
+            <a:endParaRPr lang="en-US"/>
+          </a:p>
+        </p:txBody>
       </p:sp>
       <p:sp>
         <p:nvSpPr>
@@ -3505,7 +3360,7 @@
           <a:bodyPr wrap="square" rtlCol="0" anchor="ctr"/>
           <a:lstStyle/>
           <a:p>
-            <a:pPr algn="ctr" indent="0" marL="0">
+            <a:pPr marL="0" indent="0" algn="ctr">
               <a:buNone/>
             </a:pPr>
             <a:r>
@@ -3544,7 +3399,7 @@
           <a:bodyPr wrap="square" rtlCol="0" anchor="ctr"/>
           <a:lstStyle/>
           <a:p>
-            <a:pPr algn="ctr" indent="0" marL="0">
+            <a:pPr marL="0" indent="0" algn="ctr">
               <a:buNone/>
             </a:pPr>
             <a:r>
@@ -3564,217 +3419,7 @@
       </p:sp>
       <p:pic>
         <p:nvPicPr>
-          <p:cNvPr id="9" name="Image 0" descr="preencoded.png">    </p:cNvPr>
-          <p:cNvPicPr>
-            <a:picLocks noChangeAspect="1"/>
-          </p:cNvPicPr>
-          <p:nvPr/>
-        </p:nvPicPr>
-        <p:blipFill>
-          <a:blip r:embed="rId1"/>
-          <a:stretch>
-            <a:fillRect/>
-          </a:stretch>
-        </p:blipFill>
-        <p:spPr>
-          <a:xfrm>
-            <a:off x="4297680" y="1417320"/>
-            <a:ext cx="365760" cy="365760"/>
-          </a:xfrm>
-          <a:prstGeom prst="rect">
-            <a:avLst/>
-          </a:prstGeom>
-        </p:spPr>
-      </p:pic>
-      <p:sp>
-        <p:nvSpPr>
-          <p:cNvPr id="10" name="Text 7"/>
-          <p:cNvSpPr/>
-          <p:nvPr/>
-        </p:nvSpPr>
-        <p:spPr>
-          <a:xfrm>
-            <a:off x="4800600" y="1362456"/>
-            <a:ext cx="6675120" cy="365760"/>
-          </a:xfrm>
-          <a:prstGeom prst="rect">
-            <a:avLst/>
-          </a:prstGeom>
-          <a:noFill/>
-          <a:ln/>
-        </p:spPr>
-        <p:txBody>
-          <a:bodyPr wrap="square" rtlCol="0" anchor="ctr"/>
-          <a:lstStyle/>
-          <a:p>
-            <a:pPr indent="0" marL="0">
-              <a:buNone/>
-            </a:pPr>
-            <a:r>
-              <a:rPr lang="en-US" sz="1500" b="1" dirty="0">
-                <a:solidFill>
-                  <a:srgbClr val="1E2761"/>
-                </a:solidFill>
-                <a:latin typeface="Calibri" pitchFamily="34" charset="0"/>
-                <a:ea typeface="Calibri" pitchFamily="34" charset="-122"/>
-                <a:cs typeface="Calibri" pitchFamily="34" charset="-120"/>
-              </a:rPr>
-              <a:t>Absorb high-volume triage</a:t>
-            </a:r>
-            <a:endParaRPr lang="en-US" sz="1500" dirty="0"/>
-          </a:p>
-        </p:txBody>
-      </p:sp>
-      <p:sp>
-        <p:nvSpPr>
-          <p:cNvPr id="11" name="Text 8"/>
-          <p:cNvSpPr/>
-          <p:nvPr/>
-        </p:nvSpPr>
-        <p:spPr>
-          <a:xfrm>
-            <a:off x="4800600" y="1746504"/>
-            <a:ext cx="6675120" cy="777240"/>
-          </a:xfrm>
-          <a:prstGeom prst="rect">
-            <a:avLst/>
-          </a:prstGeom>
-          <a:noFill/>
-          <a:ln/>
-        </p:spPr>
-        <p:txBody>
-          <a:bodyPr wrap="square" rtlCol="0" anchor="ctr"/>
-          <a:lstStyle/>
-          <a:p>
-            <a:pPr indent="0" marL="0">
-              <a:lnSpc>
-                <a:spcPct val="120000"/>
-              </a:lnSpc>
-              <a:buNone/>
-            </a:pPr>
-            <a:r>
-              <a:rPr lang="en-US" sz="1250" dirty="0">
-                <a:solidFill>
-                  <a:srgbClr val="5B6B8C"/>
-                </a:solidFill>
-                <a:latin typeface="Calibri" pitchFamily="34" charset="0"/>
-                <a:ea typeface="Calibri" pitchFamily="34" charset="-122"/>
-                <a:cs typeface="Calibri" pitchFamily="34" charset="-120"/>
-              </a:rPr>
-              <a:t>Agentic pipelines handle rules-governed claims work at scale, freeing investigators for complex or high-dollar cases.</a:t>
-            </a:r>
-            <a:endParaRPr lang="en-US" sz="1250" dirty="0"/>
-          </a:p>
-        </p:txBody>
-      </p:sp>
-      <p:pic>
-        <p:nvPicPr>
-          <p:cNvPr id="12" name="Image 1" descr="preencoded.png">    </p:cNvPr>
-          <p:cNvPicPr>
-            <a:picLocks noChangeAspect="1"/>
-          </p:cNvPicPr>
-          <p:nvPr/>
-        </p:nvPicPr>
-        <p:blipFill>
-          <a:blip r:embed="rId2"/>
-          <a:stretch>
-            <a:fillRect/>
-          </a:stretch>
-        </p:blipFill>
-        <p:spPr>
-          <a:xfrm>
-            <a:off x="4297680" y="2834640"/>
-            <a:ext cx="365760" cy="365760"/>
-          </a:xfrm>
-          <a:prstGeom prst="rect">
-            <a:avLst/>
-          </a:prstGeom>
-        </p:spPr>
-      </p:pic>
-      <p:sp>
-        <p:nvSpPr>
-          <p:cNvPr id="13" name="Text 9"/>
-          <p:cNvSpPr/>
-          <p:nvPr/>
-        </p:nvSpPr>
-        <p:spPr>
-          <a:xfrm>
-            <a:off x="4800600" y="2779776"/>
-            <a:ext cx="6675120" cy="365760"/>
-          </a:xfrm>
-          <a:prstGeom prst="rect">
-            <a:avLst/>
-          </a:prstGeom>
-          <a:noFill/>
-          <a:ln/>
-        </p:spPr>
-        <p:txBody>
-          <a:bodyPr wrap="square" rtlCol="0" anchor="ctr"/>
-          <a:lstStyle/>
-          <a:p>
-            <a:pPr indent="0" marL="0">
-              <a:buNone/>
-            </a:pPr>
-            <a:r>
-              <a:rPr lang="en-US" sz="1500" b="1" dirty="0">
-                <a:solidFill>
-                  <a:srgbClr val="1E2761"/>
-                </a:solidFill>
-                <a:latin typeface="Calibri" pitchFamily="34" charset="0"/>
-                <a:ea typeface="Calibri" pitchFamily="34" charset="-122"/>
-                <a:cs typeface="Calibri" pitchFamily="34" charset="-120"/>
-              </a:rPr>
-              <a:t>Catch relational fraud schemes</a:t>
-            </a:r>
-            <a:endParaRPr lang="en-US" sz="1500" dirty="0"/>
-          </a:p>
-        </p:txBody>
-      </p:sp>
-      <p:sp>
-        <p:nvSpPr>
-          <p:cNvPr id="14" name="Text 10"/>
-          <p:cNvSpPr/>
-          <p:nvPr/>
-        </p:nvSpPr>
-        <p:spPr>
-          <a:xfrm>
-            <a:off x="4800600" y="3163824"/>
-            <a:ext cx="6675120" cy="777240"/>
-          </a:xfrm>
-          <a:prstGeom prst="rect">
-            <a:avLst/>
-          </a:prstGeom>
-          <a:noFill/>
-          <a:ln/>
-        </p:spPr>
-        <p:txBody>
-          <a:bodyPr wrap="square" rtlCol="0" anchor="ctr"/>
-          <a:lstStyle/>
-          <a:p>
-            <a:pPr indent="0" marL="0">
-              <a:lnSpc>
-                <a:spcPct val="120000"/>
-              </a:lnSpc>
-              <a:buNone/>
-            </a:pPr>
-            <a:r>
-              <a:rPr lang="en-US" sz="1250" dirty="0">
-                <a:solidFill>
-                  <a:srgbClr val="5B6B8C"/>
-                </a:solidFill>
-                <a:latin typeface="Calibri" pitchFamily="34" charset="0"/>
-                <a:ea typeface="Calibri" pitchFamily="34" charset="-122"/>
-                <a:cs typeface="Calibri" pitchFamily="34" charset="-120"/>
-              </a:rPr>
-              <a:t>Graph- and agent-based approaches model claims as interconnected provider–patient–facility networks, surfacing coordinated schemes simple rules miss.</a:t>
-            </a:r>
-            <a:endParaRPr lang="en-US" sz="1250" dirty="0"/>
-          </a:p>
-        </p:txBody>
-      </p:sp>
-      <p:pic>
-        <p:nvPicPr>
-          <p:cNvPr id="15" name="Image 2" descr="preencoded.png">    </p:cNvPr>
+          <p:cNvPr id="9" name="Image 0" descr="preencoded.png"/>
           <p:cNvPicPr>
             <a:picLocks noChangeAspect="1"/>
           </p:cNvPicPr>
@@ -3788,7 +3433,7 @@
         </p:blipFill>
         <p:spPr>
           <a:xfrm>
-            <a:off x="4297680" y="4251960"/>
+            <a:off x="4297680" y="1417320"/>
             <a:ext cx="365760" cy="365760"/>
           </a:xfrm>
           <a:prstGeom prst="rect">
@@ -3798,13 +3443,13 @@
       </p:pic>
       <p:sp>
         <p:nvSpPr>
-          <p:cNvPr id="16" name="Text 11"/>
-          <p:cNvSpPr/>
-          <p:nvPr/>
-        </p:nvSpPr>
-        <p:spPr>
-          <a:xfrm>
-            <a:off x="4800600" y="4197096"/>
+          <p:cNvPr id="10" name="Text 7"/>
+          <p:cNvSpPr/>
+          <p:nvPr/>
+        </p:nvSpPr>
+        <p:spPr>
+          <a:xfrm>
+            <a:off x="4800600" y="1362456"/>
             <a:ext cx="6675120" cy="365760"/>
           </a:xfrm>
           <a:prstGeom prst="rect">
@@ -3817,7 +3462,7 @@
           <a:bodyPr wrap="square" rtlCol="0" anchor="ctr"/>
           <a:lstStyle/>
           <a:p>
-            <a:pPr indent="0" marL="0">
+            <a:pPr marL="0" indent="0">
               <a:buNone/>
             </a:pPr>
             <a:r>
@@ -3829,7 +3474,7 @@
                 <a:ea typeface="Calibri" pitchFamily="34" charset="-122"/>
                 <a:cs typeface="Calibri" pitchFamily="34" charset="-120"/>
               </a:rPr>
-              <a:t>Extend, don’t replace, existing strengths</a:t>
+              <a:t>Absorb high-volume triage</a:t>
             </a:r>
             <a:endParaRPr lang="en-US" sz="1500" dirty="0"/>
           </a:p>
@@ -3837,13 +3482,13 @@
       </p:sp>
       <p:sp>
         <p:nvSpPr>
-          <p:cNvPr id="17" name="Text 12"/>
-          <p:cNvSpPr/>
-          <p:nvPr/>
-        </p:nvSpPr>
-        <p:spPr>
-          <a:xfrm>
-            <a:off x="4800600" y="4581144"/>
+          <p:cNvPr id="11" name="Text 8"/>
+          <p:cNvSpPr/>
+          <p:nvPr/>
+        </p:nvSpPr>
+        <p:spPr>
+          <a:xfrm>
+            <a:off x="4800600" y="1746504"/>
             <a:ext cx="6675120" cy="777240"/>
           </a:xfrm>
           <a:prstGeom prst="rect">
@@ -3856,7 +3501,7 @@
           <a:bodyPr wrap="square" rtlCol="0" anchor="ctr"/>
           <a:lstStyle/>
           <a:p>
-            <a:pPr indent="0" marL="0">
+            <a:pPr marL="0" indent="0">
               <a:lnSpc>
                 <a:spcPct val="120000"/>
               </a:lnSpc>
@@ -3871,6 +3516,216 @@
                 <a:ea typeface="Calibri" pitchFamily="34" charset="-122"/>
                 <a:cs typeface="Calibri" pitchFamily="34" charset="-120"/>
               </a:rPr>
+              <a:t>Agentic pipelines handle rules-governed claims work at scale, freeing investigators for complex or high-dollar cases.</a:t>
+            </a:r>
+            <a:endParaRPr lang="en-US" sz="1250" dirty="0"/>
+          </a:p>
+        </p:txBody>
+      </p:sp>
+      <p:pic>
+        <p:nvPicPr>
+          <p:cNvPr id="12" name="Image 1" descr="preencoded.png"/>
+          <p:cNvPicPr>
+            <a:picLocks noChangeAspect="1"/>
+          </p:cNvPicPr>
+          <p:nvPr/>
+        </p:nvPicPr>
+        <p:blipFill>
+          <a:blip r:embed="rId3"/>
+          <a:stretch>
+            <a:fillRect/>
+          </a:stretch>
+        </p:blipFill>
+        <p:spPr>
+          <a:xfrm>
+            <a:off x="4297680" y="2834640"/>
+            <a:ext cx="365760" cy="365760"/>
+          </a:xfrm>
+          <a:prstGeom prst="rect">
+            <a:avLst/>
+          </a:prstGeom>
+        </p:spPr>
+      </p:pic>
+      <p:sp>
+        <p:nvSpPr>
+          <p:cNvPr id="13" name="Text 9"/>
+          <p:cNvSpPr/>
+          <p:nvPr/>
+        </p:nvSpPr>
+        <p:spPr>
+          <a:xfrm>
+            <a:off x="4800600" y="2779776"/>
+            <a:ext cx="6675120" cy="365760"/>
+          </a:xfrm>
+          <a:prstGeom prst="rect">
+            <a:avLst/>
+          </a:prstGeom>
+          <a:noFill/>
+          <a:ln/>
+        </p:spPr>
+        <p:txBody>
+          <a:bodyPr wrap="square" rtlCol="0" anchor="ctr"/>
+          <a:lstStyle/>
+          <a:p>
+            <a:pPr marL="0" indent="0">
+              <a:buNone/>
+            </a:pPr>
+            <a:r>
+              <a:rPr lang="en-US" sz="1500" b="1" dirty="0">
+                <a:solidFill>
+                  <a:srgbClr val="1E2761"/>
+                </a:solidFill>
+                <a:latin typeface="Calibri" pitchFamily="34" charset="0"/>
+                <a:ea typeface="Calibri" pitchFamily="34" charset="-122"/>
+                <a:cs typeface="Calibri" pitchFamily="34" charset="-120"/>
+              </a:rPr>
+              <a:t>Catch relational fraud schemes</a:t>
+            </a:r>
+            <a:endParaRPr lang="en-US" sz="1500" dirty="0"/>
+          </a:p>
+        </p:txBody>
+      </p:sp>
+      <p:sp>
+        <p:nvSpPr>
+          <p:cNvPr id="14" name="Text 10"/>
+          <p:cNvSpPr/>
+          <p:nvPr/>
+        </p:nvSpPr>
+        <p:spPr>
+          <a:xfrm>
+            <a:off x="4800600" y="3163824"/>
+            <a:ext cx="6675120" cy="777240"/>
+          </a:xfrm>
+          <a:prstGeom prst="rect">
+            <a:avLst/>
+          </a:prstGeom>
+          <a:noFill/>
+          <a:ln/>
+        </p:spPr>
+        <p:txBody>
+          <a:bodyPr wrap="square" rtlCol="0" anchor="ctr"/>
+          <a:lstStyle/>
+          <a:p>
+            <a:pPr marL="0" indent="0">
+              <a:lnSpc>
+                <a:spcPct val="120000"/>
+              </a:lnSpc>
+              <a:buNone/>
+            </a:pPr>
+            <a:r>
+              <a:rPr lang="en-US" sz="1250" dirty="0">
+                <a:solidFill>
+                  <a:srgbClr val="5B6B8C"/>
+                </a:solidFill>
+                <a:latin typeface="Calibri" pitchFamily="34" charset="0"/>
+                <a:ea typeface="Calibri" pitchFamily="34" charset="-122"/>
+                <a:cs typeface="Calibri" pitchFamily="34" charset="-120"/>
+              </a:rPr>
+              <a:t>Graph- and agent-based approaches model claims as interconnected provider–patient–facility networks, surfacing coordinated schemes simple rules miss.</a:t>
+            </a:r>
+            <a:endParaRPr lang="en-US" sz="1250" dirty="0"/>
+          </a:p>
+        </p:txBody>
+      </p:sp>
+      <p:pic>
+        <p:nvPicPr>
+          <p:cNvPr id="15" name="Image 2" descr="preencoded.png"/>
+          <p:cNvPicPr>
+            <a:picLocks noChangeAspect="1"/>
+          </p:cNvPicPr>
+          <p:nvPr/>
+        </p:nvPicPr>
+        <p:blipFill>
+          <a:blip r:embed="rId3"/>
+          <a:stretch>
+            <a:fillRect/>
+          </a:stretch>
+        </p:blipFill>
+        <p:spPr>
+          <a:xfrm>
+            <a:off x="4297680" y="4251960"/>
+            <a:ext cx="365760" cy="365760"/>
+          </a:xfrm>
+          <a:prstGeom prst="rect">
+            <a:avLst/>
+          </a:prstGeom>
+        </p:spPr>
+      </p:pic>
+      <p:sp>
+        <p:nvSpPr>
+          <p:cNvPr id="16" name="Text 11"/>
+          <p:cNvSpPr/>
+          <p:nvPr/>
+        </p:nvSpPr>
+        <p:spPr>
+          <a:xfrm>
+            <a:off x="4800600" y="4197096"/>
+            <a:ext cx="6675120" cy="365760"/>
+          </a:xfrm>
+          <a:prstGeom prst="rect">
+            <a:avLst/>
+          </a:prstGeom>
+          <a:noFill/>
+          <a:ln/>
+        </p:spPr>
+        <p:txBody>
+          <a:bodyPr wrap="square" rtlCol="0" anchor="ctr"/>
+          <a:lstStyle/>
+          <a:p>
+            <a:pPr marL="0" indent="0">
+              <a:buNone/>
+            </a:pPr>
+            <a:r>
+              <a:rPr lang="en-US" sz="1500" b="1" dirty="0">
+                <a:solidFill>
+                  <a:srgbClr val="1E2761"/>
+                </a:solidFill>
+                <a:latin typeface="Calibri" pitchFamily="34" charset="0"/>
+                <a:ea typeface="Calibri" pitchFamily="34" charset="-122"/>
+                <a:cs typeface="Calibri" pitchFamily="34" charset="-120"/>
+              </a:rPr>
+              <a:t>Extend, don’t replace, existing strengths</a:t>
+            </a:r>
+            <a:endParaRPr lang="en-US" sz="1500" dirty="0"/>
+          </a:p>
+        </p:txBody>
+      </p:sp>
+      <p:sp>
+        <p:nvSpPr>
+          <p:cNvPr id="17" name="Text 12"/>
+          <p:cNvSpPr/>
+          <p:nvPr/>
+        </p:nvSpPr>
+        <p:spPr>
+          <a:xfrm>
+            <a:off x="4800600" y="4581144"/>
+            <a:ext cx="6675120" cy="777240"/>
+          </a:xfrm>
+          <a:prstGeom prst="rect">
+            <a:avLst/>
+          </a:prstGeom>
+          <a:noFill/>
+          <a:ln/>
+        </p:spPr>
+        <p:txBody>
+          <a:bodyPr wrap="square" rtlCol="0" anchor="ctr"/>
+          <a:lstStyle/>
+          <a:p>
+            <a:pPr marL="0" indent="0">
+              <a:lnSpc>
+                <a:spcPct val="120000"/>
+              </a:lnSpc>
+              <a:buNone/>
+            </a:pPr>
+            <a:r>
+              <a:rPr lang="en-US" sz="1250" dirty="0">
+                <a:solidFill>
+                  <a:srgbClr val="5B6B8C"/>
+                </a:solidFill>
+                <a:latin typeface="Calibri" pitchFamily="34" charset="0"/>
+                <a:ea typeface="Calibri" pitchFamily="34" charset="-122"/>
+                <a:cs typeface="Calibri" pitchFamily="34" charset="-120"/>
+              </a:rPr>
               <a:t>Cotiviti can layer agentic reasoning onto its existing payment accuracy and quality measurement capabilities.</a:t>
             </a:r>
             <a:endParaRPr lang="en-US" sz="1250" dirty="0"/>
@@ -3898,7 +3753,7 @@
           <a:bodyPr wrap="square" rtlCol="0" anchor="ctr"/>
           <a:lstStyle/>
           <a:p>
-            <a:pPr indent="0" marL="0">
+            <a:pPr marL="0" indent="0">
               <a:buNone/>
             </a:pPr>
             <a:r>
@@ -3932,6 +3787,7 @@
         <a:solidFill>
           <a:srgbClr val="FFFFFF"/>
         </a:solidFill>
+        <a:effectLst/>
       </p:bgPr>
     </p:bg>
     <p:spTree>
@@ -3969,7 +3825,7 @@
           <a:bodyPr wrap="square" rtlCol="0" anchor="ctr"/>
           <a:lstStyle/>
           <a:p>
-            <a:pPr indent="0" marL="0">
+            <a:pPr marL="0" indent="0">
               <a:buNone/>
             </a:pPr>
             <a:r>
@@ -4008,6 +3864,13 @@
           </a:solidFill>
           <a:ln/>
         </p:spPr>
+        <p:txBody>
+          <a:bodyPr/>
+          <a:lstStyle/>
+          <a:p>
+            <a:endParaRPr lang="en-US"/>
+          </a:p>
+        </p:txBody>
       </p:sp>
       <p:sp>
         <p:nvSpPr>
@@ -4033,17 +3896,24 @@
             <a:prstDash val="solid"/>
           </a:ln>
         </p:spPr>
+        <p:txBody>
+          <a:bodyPr/>
+          <a:lstStyle/>
+          <a:p>
+            <a:endParaRPr lang="en-US"/>
+          </a:p>
+        </p:txBody>
       </p:sp>
       <p:pic>
         <p:nvPicPr>
-          <p:cNvPr id="5" name="Image 0" descr="preencoded.png">    </p:cNvPr>
+          <p:cNvPr id="5" name="Image 0" descr="preencoded.png"/>
           <p:cNvPicPr>
             <a:picLocks noChangeAspect="1"/>
           </p:cNvPicPr>
           <p:nvPr/>
         </p:nvPicPr>
         <p:blipFill>
-          <a:blip r:embed="rId1"/>
+          <a:blip r:embed="rId3"/>
           <a:stretch>
             <a:fillRect/>
           </a:stretch>
@@ -4079,7 +3949,7 @@
           <a:bodyPr wrap="square" rtlCol="0" anchor="ctr"/>
           <a:lstStyle/>
           <a:p>
-            <a:pPr indent="0" marL="0">
+            <a:pPr marL="0" indent="0">
               <a:buNone/>
             </a:pPr>
             <a:r>
@@ -4118,7 +3988,7 @@
           <a:bodyPr wrap="square" rtlCol="0" anchor="ctr"/>
           <a:lstStyle/>
           <a:p>
-            <a:pPr indent="0" marL="0">
+            <a:pPr marL="0" indent="0">
               <a:lnSpc>
                 <a:spcPct val="120000"/>
               </a:lnSpc>
@@ -4160,6 +4030,13 @@
           </a:solidFill>
           <a:ln/>
         </p:spPr>
+        <p:txBody>
+          <a:bodyPr/>
+          <a:lstStyle/>
+          <a:p>
+            <a:endParaRPr lang="en-US"/>
+          </a:p>
+        </p:txBody>
       </p:sp>
       <p:sp>
         <p:nvSpPr>
@@ -4185,17 +4062,24 @@
             <a:prstDash val="solid"/>
           </a:ln>
         </p:spPr>
+        <p:txBody>
+          <a:bodyPr/>
+          <a:lstStyle/>
+          <a:p>
+            <a:endParaRPr lang="en-US"/>
+          </a:p>
+        </p:txBody>
       </p:sp>
       <p:pic>
         <p:nvPicPr>
-          <p:cNvPr id="10" name="Image 1" descr="preencoded.png">    </p:cNvPr>
+          <p:cNvPr id="10" name="Image 1" descr="preencoded.png"/>
           <p:cNvPicPr>
             <a:picLocks noChangeAspect="1"/>
           </p:cNvPicPr>
           <p:nvPr/>
         </p:nvPicPr>
         <p:blipFill>
-          <a:blip r:embed="rId2"/>
+          <a:blip r:embed="rId3"/>
           <a:stretch>
             <a:fillRect/>
           </a:stretch>
@@ -4231,7 +4115,7 @@
           <a:bodyPr wrap="square" rtlCol="0" anchor="ctr"/>
           <a:lstStyle/>
           <a:p>
-            <a:pPr indent="0" marL="0">
+            <a:pPr marL="0" indent="0">
               <a:buNone/>
             </a:pPr>
             <a:r>
@@ -4270,7 +4154,7 @@
           <a:bodyPr wrap="square" rtlCol="0" anchor="ctr"/>
           <a:lstStyle/>
           <a:p>
-            <a:pPr indent="0" marL="0">
+            <a:pPr marL="0" indent="0">
               <a:lnSpc>
                 <a:spcPct val="120000"/>
               </a:lnSpc>
@@ -4312,6 +4196,13 @@
           </a:solidFill>
           <a:ln/>
         </p:spPr>
+        <p:txBody>
+          <a:bodyPr/>
+          <a:lstStyle/>
+          <a:p>
+            <a:endParaRPr lang="en-US"/>
+          </a:p>
+        </p:txBody>
       </p:sp>
       <p:sp>
         <p:nvSpPr>
@@ -4337,10 +4228,17 @@
             <a:prstDash val="solid"/>
           </a:ln>
         </p:spPr>
+        <p:txBody>
+          <a:bodyPr/>
+          <a:lstStyle/>
+          <a:p>
+            <a:endParaRPr lang="en-US"/>
+          </a:p>
+        </p:txBody>
       </p:sp>
       <p:pic>
         <p:nvPicPr>
-          <p:cNvPr id="15" name="Image 2" descr="preencoded.png">    </p:cNvPr>
+          <p:cNvPr id="15" name="Image 2" descr="preencoded.png"/>
           <p:cNvPicPr>
             <a:picLocks noChangeAspect="1"/>
           </p:cNvPicPr>
@@ -4383,7 +4281,7 @@
           <a:bodyPr wrap="square" rtlCol="0" anchor="ctr"/>
           <a:lstStyle/>
           <a:p>
-            <a:pPr indent="0" marL="0">
+            <a:pPr marL="0" indent="0">
               <a:buNone/>
             </a:pPr>
             <a:r>
@@ -4422,7 +4320,7 @@
           <a:bodyPr wrap="square" rtlCol="0" anchor="ctr"/>
           <a:lstStyle/>
           <a:p>
-            <a:pPr indent="0" marL="0">
+            <a:pPr marL="0" indent="0">
               <a:lnSpc>
                 <a:spcPct val="120000"/>
               </a:lnSpc>
@@ -4464,7 +4362,7 @@
           <a:bodyPr wrap="square" rtlCol="0" anchor="ctr"/>
           <a:lstStyle/>
           <a:p>
-            <a:pPr indent="0" marL="0">
+            <a:pPr marL="0" indent="0">
               <a:buNone/>
             </a:pPr>
             <a:r>
@@ -4498,6 +4396,7 @@
         <a:solidFill>
           <a:srgbClr val="FFFFFF"/>
         </a:solidFill>
+        <a:effectLst/>
       </p:bgPr>
     </p:bg>
     <p:spTree>
@@ -4535,7 +4434,7 @@
           <a:bodyPr wrap="square" rtlCol="0" anchor="ctr"/>
           <a:lstStyle/>
           <a:p>
-            <a:pPr indent="0" marL="0">
+            <a:pPr marL="0" indent="0">
               <a:buNone/>
             </a:pPr>
             <a:r>
@@ -4574,7 +4473,7 @@
           <a:bodyPr wrap="square" rtlCol="0" anchor="ctr"/>
           <a:lstStyle/>
           <a:p>
-            <a:pPr indent="0" marL="0">
+            <a:pPr marL="0" indent="0">
               <a:buNone/>
             </a:pPr>
             <a:r>
@@ -4613,13 +4512,20 @@
           </a:solidFill>
           <a:ln/>
           <a:effectLst>
-            <a:outerShdw sx="100000" sy="100000" kx="0" ky="0" algn="bl" rotWithShape="0" blurRad="101600" dist="38100" dir="5400000">
+            <a:outerShdw blurRad="101600" dist="38100" dir="5400000" algn="bl" rotWithShape="0">
               <a:srgbClr val="1E2761">
                 <a:alpha val="10000"/>
               </a:srgbClr>
             </a:outerShdw>
           </a:effectLst>
         </p:spPr>
+        <p:txBody>
+          <a:bodyPr/>
+          <a:lstStyle/>
+          <a:p>
+            <a:endParaRPr lang="en-US"/>
+          </a:p>
+        </p:txBody>
       </p:sp>
       <p:sp>
         <p:nvSpPr>
@@ -4640,6 +4546,13 @@
           </a:solidFill>
           <a:ln/>
         </p:spPr>
+        <p:txBody>
+          <a:bodyPr/>
+          <a:lstStyle/>
+          <a:p>
+            <a:endParaRPr lang="en-US"/>
+          </a:p>
+        </p:txBody>
       </p:sp>
       <p:sp>
         <p:nvSpPr>
@@ -4662,7 +4575,7 @@
           <a:bodyPr wrap="square" rtlCol="0" anchor="ctr"/>
           <a:lstStyle/>
           <a:p>
-            <a:pPr algn="ctr" indent="0" marL="0">
+            <a:pPr marL="0" indent="0" algn="ctr">
               <a:buNone/>
             </a:pPr>
             <a:r>
@@ -4701,7 +4614,7 @@
           <a:bodyPr wrap="square" rtlCol="0" anchor="ctr"/>
           <a:lstStyle/>
           <a:p>
-            <a:pPr indent="0" marL="0">
+            <a:pPr marL="0" indent="0">
               <a:lnSpc>
                 <a:spcPct val="110000"/>
               </a:lnSpc>
@@ -4743,7 +4656,7 @@
           <a:bodyPr wrap="square" rtlCol="0" anchor="ctr"/>
           <a:lstStyle/>
           <a:p>
-            <a:pPr indent="0" marL="0">
+            <a:pPr marL="0" indent="0">
               <a:lnSpc>
                 <a:spcPct val="125000"/>
               </a:lnSpc>
@@ -4785,13 +4698,20 @@
           </a:solidFill>
           <a:ln/>
           <a:effectLst>
-            <a:outerShdw sx="100000" sy="100000" kx="0" ky="0" algn="bl" rotWithShape="0" blurRad="101600" dist="38100" dir="5400000">
+            <a:outerShdw blurRad="101600" dist="38100" dir="5400000" algn="bl" rotWithShape="0">
               <a:srgbClr val="1E2761">
                 <a:alpha val="10000"/>
               </a:srgbClr>
             </a:outerShdw>
           </a:effectLst>
         </p:spPr>
+        <p:txBody>
+          <a:bodyPr/>
+          <a:lstStyle/>
+          <a:p>
+            <a:endParaRPr lang="en-US"/>
+          </a:p>
+        </p:txBody>
       </p:sp>
       <p:sp>
         <p:nvSpPr>
@@ -4812,6 +4732,13 @@
           </a:solidFill>
           <a:ln/>
         </p:spPr>
+        <p:txBody>
+          <a:bodyPr/>
+          <a:lstStyle/>
+          <a:p>
+            <a:endParaRPr lang="en-US"/>
+          </a:p>
+        </p:txBody>
       </p:sp>
       <p:sp>
         <p:nvSpPr>
@@ -4834,7 +4761,7 @@
           <a:bodyPr wrap="square" rtlCol="0" anchor="ctr"/>
           <a:lstStyle/>
           <a:p>
-            <a:pPr algn="ctr" indent="0" marL="0">
+            <a:pPr marL="0" indent="0" algn="ctr">
               <a:buNone/>
             </a:pPr>
             <a:r>
@@ -4873,7 +4800,7 @@
           <a:bodyPr wrap="square" rtlCol="0" anchor="ctr"/>
           <a:lstStyle/>
           <a:p>
-            <a:pPr indent="0" marL="0">
+            <a:pPr marL="0" indent="0">
               <a:lnSpc>
                 <a:spcPct val="110000"/>
               </a:lnSpc>
@@ -4915,7 +4842,7 @@
           <a:bodyPr wrap="square" rtlCol="0" anchor="ctr"/>
           <a:lstStyle/>
           <a:p>
-            <a:pPr indent="0" marL="0">
+            <a:pPr marL="0" indent="0">
               <a:lnSpc>
                 <a:spcPct val="125000"/>
               </a:lnSpc>
@@ -4952,6 +4879,7 @@
         <a:solidFill>
           <a:srgbClr val="1E2761"/>
         </a:solidFill>
+        <a:effectLst/>
       </p:bgPr>
     </p:bg>
     <p:spTree>
@@ -4989,7 +4917,7 @@
           <a:bodyPr wrap="square" rtlCol="0" anchor="ctr"/>
           <a:lstStyle/>
           <a:p>
-            <a:pPr indent="0" marL="0">
+            <a:pPr marL="0" indent="0">
               <a:buNone/>
             </a:pPr>
             <a:r>
@@ -5028,7 +4956,7 @@
           <a:bodyPr wrap="square" rtlCol="0" anchor="ctr"/>
           <a:lstStyle/>
           <a:p>
-            <a:pPr indent="0" marL="0">
+            <a:pPr marL="0" indent="0">
               <a:buNone/>
             </a:pPr>
             <a:r>
@@ -5067,6 +4995,13 @@
           </a:solidFill>
           <a:ln/>
         </p:spPr>
+        <p:txBody>
+          <a:bodyPr/>
+          <a:lstStyle/>
+          <a:p>
+            <a:endParaRPr lang="en-US"/>
+          </a:p>
+        </p:txBody>
       </p:sp>
       <p:sp>
         <p:nvSpPr>
@@ -5087,220 +5022,17 @@
           </a:solidFill>
           <a:ln/>
         </p:spPr>
+        <p:txBody>
+          <a:bodyPr/>
+          <a:lstStyle/>
+          <a:p>
+            <a:endParaRPr lang="en-US"/>
+          </a:p>
+        </p:txBody>
       </p:sp>
       <p:pic>
         <p:nvPicPr>
-          <p:cNvPr id="6" name="Image 0" descr="preencoded.png">    </p:cNvPr>
-          <p:cNvPicPr>
-            <a:picLocks noChangeAspect="1"/>
-          </p:cNvPicPr>
-          <p:nvPr/>
-        </p:nvPicPr>
-        <p:blipFill>
-          <a:blip r:embed="rId1"/>
-          <a:stretch>
-            <a:fillRect/>
-          </a:stretch>
-        </p:blipFill>
-        <p:spPr>
-          <a:xfrm>
-            <a:off x="969264" y="2340864"/>
-            <a:ext cx="347472" cy="347472"/>
-          </a:xfrm>
-          <a:prstGeom prst="rect">
-            <a:avLst/>
-          </a:prstGeom>
-        </p:spPr>
-      </p:pic>
-      <p:sp>
-        <p:nvSpPr>
-          <p:cNvPr id="7" name="Text 4"/>
-          <p:cNvSpPr/>
-          <p:nvPr/>
-        </p:nvSpPr>
-        <p:spPr>
-          <a:xfrm>
-            <a:off x="822960" y="2926080"/>
-            <a:ext cx="2743200" cy="274320"/>
-          </a:xfrm>
-          <a:prstGeom prst="rect">
-            <a:avLst/>
-          </a:prstGeom>
-          <a:noFill/>
-          <a:ln/>
-        </p:spPr>
-        <p:txBody>
-          <a:bodyPr wrap="square" rtlCol="0" anchor="ctr"/>
-          <a:lstStyle/>
-          <a:p>
-            <a:pPr indent="0" marL="0">
-              <a:buNone/>
-            </a:pPr>
-            <a:r>
-              <a:rPr lang="en-US" sz="1200" b="1" spc="100" kern="0" dirty="0">
-                <a:solidFill>
-                  <a:srgbClr val="00A896"/>
-                </a:solidFill>
-                <a:latin typeface="Calibri" pitchFamily="34" charset="0"/>
-                <a:ea typeface="Calibri" pitchFamily="34" charset="-122"/>
-                <a:cs typeface="Calibri" pitchFamily="34" charset="-120"/>
-              </a:rPr>
-              <a:t>Agent 1</a:t>
-            </a:r>
-            <a:endParaRPr lang="en-US" sz="1200" dirty="0"/>
-          </a:p>
-        </p:txBody>
-      </p:sp>
-      <p:sp>
-        <p:nvSpPr>
-          <p:cNvPr id="8" name="Text 5"/>
-          <p:cNvSpPr/>
-          <p:nvPr/>
-        </p:nvSpPr>
-        <p:spPr>
-          <a:xfrm>
-            <a:off x="822960" y="3200400"/>
-            <a:ext cx="2743200" cy="411480"/>
-          </a:xfrm>
-          <a:prstGeom prst="rect">
-            <a:avLst/>
-          </a:prstGeom>
-          <a:noFill/>
-          <a:ln/>
-        </p:spPr>
-        <p:txBody>
-          <a:bodyPr wrap="square" rtlCol="0" anchor="ctr"/>
-          <a:lstStyle/>
-          <a:p>
-            <a:pPr indent="0" marL="0">
-              <a:buNone/>
-            </a:pPr>
-            <a:r>
-              <a:rPr lang="en-US" sz="1700" b="1" dirty="0">
-                <a:solidFill>
-                  <a:srgbClr val="FFFFFF"/>
-                </a:solidFill>
-                <a:latin typeface="Calibri" pitchFamily="34" charset="0"/>
-                <a:ea typeface="Calibri" pitchFamily="34" charset="-122"/>
-                <a:cs typeface="Calibri" pitchFamily="34" charset="-120"/>
-              </a:rPr>
-              <a:t>Anomaly Detector</a:t>
-            </a:r>
-            <a:endParaRPr lang="en-US" sz="1700" dirty="0"/>
-          </a:p>
-        </p:txBody>
-      </p:sp>
-      <p:sp>
-        <p:nvSpPr>
-          <p:cNvPr id="9" name="Text 6"/>
-          <p:cNvSpPr/>
-          <p:nvPr/>
-        </p:nvSpPr>
-        <p:spPr>
-          <a:xfrm>
-            <a:off x="822960" y="3657600"/>
-            <a:ext cx="2743200" cy="1371600"/>
-          </a:xfrm>
-          <a:prstGeom prst="rect">
-            <a:avLst/>
-          </a:prstGeom>
-          <a:noFill/>
-          <a:ln/>
-        </p:spPr>
-        <p:txBody>
-          <a:bodyPr wrap="square" rtlCol="0" anchor="ctr"/>
-          <a:lstStyle/>
-          <a:p>
-            <a:pPr indent="0" marL="0">
-              <a:lnSpc>
-                <a:spcPct val="125000"/>
-              </a:lnSpc>
-              <a:buNone/>
-            </a:pPr>
-            <a:r>
-              <a:rPr lang="en-US" sz="1200" dirty="0">
-                <a:solidFill>
-                  <a:srgbClr val="CADCFC"/>
-                </a:solidFill>
-                <a:latin typeface="Calibri" pitchFamily="34" charset="0"/>
-                <a:ea typeface="Calibri" pitchFamily="34" charset="-122"/>
-                <a:cs typeface="Calibri" pitchFamily="34" charset="-120"/>
-              </a:rPr>
-              <a:t>Isolation Forest flags claims priced well outside the peer norm for that procedure code.</a:t>
-            </a:r>
-            <a:endParaRPr lang="en-US" sz="1200" dirty="0"/>
-          </a:p>
-        </p:txBody>
-      </p:sp>
-      <p:pic>
-        <p:nvPicPr>
-          <p:cNvPr id="10" name="Image 1" descr="preencoded.png">    </p:cNvPr>
-          <p:cNvPicPr>
-            <a:picLocks noChangeAspect="1"/>
-          </p:cNvPicPr>
-          <p:nvPr/>
-        </p:nvPicPr>
-        <p:blipFill>
-          <a:blip r:embed="rId2"/>
-          <a:stretch>
-            <a:fillRect/>
-          </a:stretch>
-        </p:blipFill>
-        <p:spPr>
-          <a:xfrm>
-            <a:off x="3913632" y="3337560"/>
-            <a:ext cx="365760" cy="365760"/>
-          </a:xfrm>
-          <a:prstGeom prst="rect">
-            <a:avLst/>
-          </a:prstGeom>
-        </p:spPr>
-      </p:pic>
-      <p:sp>
-        <p:nvSpPr>
-          <p:cNvPr id="11" name="Shape 7"/>
-          <p:cNvSpPr/>
-          <p:nvPr/>
-        </p:nvSpPr>
-        <p:spPr>
-          <a:xfrm>
-            <a:off x="4434840" y="1920240"/>
-            <a:ext cx="3291840" cy="3200400"/>
-          </a:xfrm>
-          <a:prstGeom prst="roundRect">
-            <a:avLst>
-              <a:gd name="adj" fmla="val 2286"/>
-            </a:avLst>
-          </a:prstGeom>
-          <a:solidFill>
-            <a:srgbClr val="26316B"/>
-          </a:solidFill>
-          <a:ln/>
-        </p:spPr>
-      </p:sp>
-      <p:sp>
-        <p:nvSpPr>
-          <p:cNvPr id="12" name="Shape 8"/>
-          <p:cNvSpPr/>
-          <p:nvPr/>
-        </p:nvSpPr>
-        <p:spPr>
-          <a:xfrm>
-            <a:off x="4709160" y="2194560"/>
-            <a:ext cx="640080" cy="640080"/>
-          </a:xfrm>
-          <a:prstGeom prst="ellipse">
-            <a:avLst/>
-          </a:prstGeom>
-          <a:solidFill>
-            <a:srgbClr val="00A896"/>
-          </a:solidFill>
-          <a:ln/>
-        </p:spPr>
-      </p:sp>
-      <p:pic>
-        <p:nvPicPr>
-          <p:cNvPr id="13" name="Image 2" descr="preencoded.png">    </p:cNvPr>
+          <p:cNvPr id="6" name="Image 0" descr="preencoded.png"/>
           <p:cNvPicPr>
             <a:picLocks noChangeAspect="1"/>
           </p:cNvPicPr>
@@ -5314,7 +5046,7 @@
         </p:blipFill>
         <p:spPr>
           <a:xfrm>
-            <a:off x="4855464" y="2340864"/>
+            <a:off x="969264" y="2340864"/>
             <a:ext cx="347472" cy="347472"/>
           </a:xfrm>
           <a:prstGeom prst="rect">
@@ -5324,13 +5056,13 @@
       </p:pic>
       <p:sp>
         <p:nvSpPr>
-          <p:cNvPr id="14" name="Text 9"/>
-          <p:cNvSpPr/>
-          <p:nvPr/>
-        </p:nvSpPr>
-        <p:spPr>
-          <a:xfrm>
-            <a:off x="4709160" y="2926080"/>
+          <p:cNvPr id="7" name="Text 4"/>
+          <p:cNvSpPr/>
+          <p:nvPr/>
+        </p:nvSpPr>
+        <p:spPr>
+          <a:xfrm>
+            <a:off x="822960" y="2926080"/>
             <a:ext cx="2743200" cy="274320"/>
           </a:xfrm>
           <a:prstGeom prst="rect">
@@ -5343,11 +5075,11 @@
           <a:bodyPr wrap="square" rtlCol="0" anchor="ctr"/>
           <a:lstStyle/>
           <a:p>
-            <a:pPr indent="0" marL="0">
-              <a:buNone/>
-            </a:pPr>
-            <a:r>
-              <a:rPr lang="en-US" sz="1200" b="1" spc="100" kern="0" dirty="0">
+            <a:pPr marL="0" indent="0">
+              <a:buNone/>
+            </a:pPr>
+            <a:r>
+              <a:rPr lang="en-US" sz="1200" b="1" kern="0" spc="100" dirty="0">
                 <a:solidFill>
                   <a:srgbClr val="00A896"/>
                 </a:solidFill>
@@ -5355,7 +5087,7 @@
                 <a:ea typeface="Calibri" pitchFamily="34" charset="-122"/>
                 <a:cs typeface="Calibri" pitchFamily="34" charset="-120"/>
               </a:rPr>
-              <a:t>Agent 2</a:t>
+              <a:t>Agent 1</a:t>
             </a:r>
             <a:endParaRPr lang="en-US" sz="1200" dirty="0"/>
           </a:p>
@@ -5363,13 +5095,13 @@
       </p:sp>
       <p:sp>
         <p:nvSpPr>
-          <p:cNvPr id="15" name="Text 10"/>
-          <p:cNvSpPr/>
-          <p:nvPr/>
-        </p:nvSpPr>
-        <p:spPr>
-          <a:xfrm>
-            <a:off x="4709160" y="3200400"/>
+          <p:cNvPr id="8" name="Text 5"/>
+          <p:cNvSpPr/>
+          <p:nvPr/>
+        </p:nvSpPr>
+        <p:spPr>
+          <a:xfrm>
+            <a:off x="822960" y="3200400"/>
             <a:ext cx="2743200" cy="411480"/>
           </a:xfrm>
           <a:prstGeom prst="rect">
@@ -5382,7 +5114,7 @@
           <a:bodyPr wrap="square" rtlCol="0" anchor="ctr"/>
           <a:lstStyle/>
           <a:p>
-            <a:pPr indent="0" marL="0">
+            <a:pPr marL="0" indent="0">
               <a:buNone/>
             </a:pPr>
             <a:r>
@@ -5394,7 +5126,7 @@
                 <a:ea typeface="Calibri" pitchFamily="34" charset="-122"/>
                 <a:cs typeface="Calibri" pitchFamily="34" charset="-120"/>
               </a:rPr>
-              <a:t>Classifier</a:t>
+              <a:t>Anomaly Detector</a:t>
             </a:r>
             <a:endParaRPr lang="en-US" sz="1700" dirty="0"/>
           </a:p>
@@ -5402,13 +5134,13 @@
       </p:sp>
       <p:sp>
         <p:nvSpPr>
-          <p:cNvPr id="16" name="Text 11"/>
-          <p:cNvSpPr/>
-          <p:nvPr/>
-        </p:nvSpPr>
-        <p:spPr>
-          <a:xfrm>
-            <a:off x="4709160" y="3657600"/>
+          <p:cNvPr id="9" name="Text 6"/>
+          <p:cNvSpPr/>
+          <p:nvPr/>
+        </p:nvSpPr>
+        <p:spPr>
+          <a:xfrm>
+            <a:off x="822960" y="3657600"/>
             <a:ext cx="2743200" cy="1371600"/>
           </a:xfrm>
           <a:prstGeom prst="rect">
@@ -5421,7 +5153,7 @@
           <a:bodyPr wrap="square" rtlCol="0" anchor="ctr"/>
           <a:lstStyle/>
           <a:p>
-            <a:pPr indent="0" marL="0">
+            <a:pPr marL="0" indent="0">
               <a:lnSpc>
                 <a:spcPct val="125000"/>
               </a:lnSpc>
@@ -5436,7 +5168,7 @@
                 <a:ea typeface="Calibri" pitchFamily="34" charset="-122"/>
                 <a:cs typeface="Calibri" pitchFamily="34" charset="-120"/>
               </a:rPr>
-              <a:t>Rule-based triage labels why a claim was flagged: upcoding, unbundling, duplicate billing.</a:t>
+              <a:t>Isolation Forest flags claims priced well outside the peer norm for that procedure code.</a:t>
             </a:r>
             <a:endParaRPr lang="en-US" sz="1200" dirty="0"/>
           </a:p>
@@ -5444,7 +5176,7 @@
       </p:sp>
       <p:pic>
         <p:nvPicPr>
-          <p:cNvPr id="17" name="Image 3" descr="preencoded.png">    </p:cNvPr>
+          <p:cNvPr id="10" name="Image 1" descr="preencoded.png"/>
           <p:cNvPicPr>
             <a:picLocks noChangeAspect="1"/>
           </p:cNvPicPr>
@@ -5458,7 +5190,7 @@
         </p:blipFill>
         <p:spPr>
           <a:xfrm>
-            <a:off x="7799832" y="3337560"/>
+            <a:off x="3913632" y="3337560"/>
             <a:ext cx="365760" cy="365760"/>
           </a:xfrm>
           <a:prstGeom prst="rect">
@@ -5468,13 +5200,13 @@
       </p:pic>
       <p:sp>
         <p:nvSpPr>
-          <p:cNvPr id="18" name="Shape 12"/>
-          <p:cNvSpPr/>
-          <p:nvPr/>
-        </p:nvSpPr>
-        <p:spPr>
-          <a:xfrm>
-            <a:off x="8321040" y="1920240"/>
+          <p:cNvPr id="11" name="Shape 7"/>
+          <p:cNvSpPr/>
+          <p:nvPr/>
+        </p:nvSpPr>
+        <p:spPr>
+          <a:xfrm>
+            <a:off x="4434840" y="1920240"/>
             <a:ext cx="3291840" cy="3200400"/>
           </a:xfrm>
           <a:prstGeom prst="roundRect">
@@ -5487,16 +5219,23 @@
           </a:solidFill>
           <a:ln/>
         </p:spPr>
-      </p:sp>
-      <p:sp>
-        <p:nvSpPr>
-          <p:cNvPr id="19" name="Shape 13"/>
-          <p:cNvSpPr/>
-          <p:nvPr/>
-        </p:nvSpPr>
-        <p:spPr>
-          <a:xfrm>
-            <a:off x="8595360" y="2194560"/>
+        <p:txBody>
+          <a:bodyPr/>
+          <a:lstStyle/>
+          <a:p>
+            <a:endParaRPr lang="en-US"/>
+          </a:p>
+        </p:txBody>
+      </p:sp>
+      <p:sp>
+        <p:nvSpPr>
+          <p:cNvPr id="12" name="Shape 8"/>
+          <p:cNvSpPr/>
+          <p:nvPr/>
+        </p:nvSpPr>
+        <p:spPr>
+          <a:xfrm>
+            <a:off x="4709160" y="2194560"/>
             <a:ext cx="640080" cy="640080"/>
           </a:xfrm>
           <a:prstGeom prst="ellipse">
@@ -5507,10 +5246,17 @@
           </a:solidFill>
           <a:ln/>
         </p:spPr>
+        <p:txBody>
+          <a:bodyPr/>
+          <a:lstStyle/>
+          <a:p>
+            <a:endParaRPr lang="en-US"/>
+          </a:p>
+        </p:txBody>
       </p:sp>
       <p:pic>
         <p:nvPicPr>
-          <p:cNvPr id="20" name="Image 4" descr="preencoded.png">    </p:cNvPr>
+          <p:cNvPr id="13" name="Image 2" descr="preencoded.png"/>
           <p:cNvPicPr>
             <a:picLocks noChangeAspect="1"/>
           </p:cNvPicPr>
@@ -5524,7 +5270,7 @@
         </p:blipFill>
         <p:spPr>
           <a:xfrm>
-            <a:off x="8741664" y="2340864"/>
+            <a:off x="4855464" y="2340864"/>
             <a:ext cx="347472" cy="347472"/>
           </a:xfrm>
           <a:prstGeom prst="rect">
@@ -5534,13 +5280,13 @@
       </p:pic>
       <p:sp>
         <p:nvSpPr>
-          <p:cNvPr id="21" name="Text 14"/>
-          <p:cNvSpPr/>
-          <p:nvPr/>
-        </p:nvSpPr>
-        <p:spPr>
-          <a:xfrm>
-            <a:off x="8595360" y="2926080"/>
+          <p:cNvPr id="14" name="Text 9"/>
+          <p:cNvSpPr/>
+          <p:nvPr/>
+        </p:nvSpPr>
+        <p:spPr>
+          <a:xfrm>
+            <a:off x="4709160" y="2926080"/>
             <a:ext cx="2743200" cy="274320"/>
           </a:xfrm>
           <a:prstGeom prst="rect">
@@ -5553,11 +5299,11 @@
           <a:bodyPr wrap="square" rtlCol="0" anchor="ctr"/>
           <a:lstStyle/>
           <a:p>
-            <a:pPr indent="0" marL="0">
-              <a:buNone/>
-            </a:pPr>
-            <a:r>
-              <a:rPr lang="en-US" sz="1200" b="1" spc="100" kern="0" dirty="0">
+            <a:pPr marL="0" indent="0">
+              <a:buNone/>
+            </a:pPr>
+            <a:r>
+              <a:rPr lang="en-US" sz="1200" b="1" kern="0" spc="100" dirty="0">
                 <a:solidFill>
                   <a:srgbClr val="00A896"/>
                 </a:solidFill>
@@ -5565,7 +5311,7 @@
                 <a:ea typeface="Calibri" pitchFamily="34" charset="-122"/>
                 <a:cs typeface="Calibri" pitchFamily="34" charset="-120"/>
               </a:rPr>
-              <a:t>Agent 3</a:t>
+              <a:t>Agent 2</a:t>
             </a:r>
             <a:endParaRPr lang="en-US" sz="1200" dirty="0"/>
           </a:p>
@@ -5573,13 +5319,13 @@
       </p:sp>
       <p:sp>
         <p:nvSpPr>
-          <p:cNvPr id="22" name="Text 15"/>
-          <p:cNvSpPr/>
-          <p:nvPr/>
-        </p:nvSpPr>
-        <p:spPr>
-          <a:xfrm>
-            <a:off x="8595360" y="3200400"/>
+          <p:cNvPr id="15" name="Text 10"/>
+          <p:cNvSpPr/>
+          <p:nvPr/>
+        </p:nvSpPr>
+        <p:spPr>
+          <a:xfrm>
+            <a:off x="4709160" y="3200400"/>
             <a:ext cx="2743200" cy="411480"/>
           </a:xfrm>
           <a:prstGeom prst="rect">
@@ -5592,7 +5338,7 @@
           <a:bodyPr wrap="square" rtlCol="0" anchor="ctr"/>
           <a:lstStyle/>
           <a:p>
-            <a:pPr indent="0" marL="0">
+            <a:pPr marL="0" indent="0">
               <a:buNone/>
             </a:pPr>
             <a:r>
@@ -5604,7 +5350,7 @@
                 <a:ea typeface="Calibri" pitchFamily="34" charset="-122"/>
                 <a:cs typeface="Calibri" pitchFamily="34" charset="-120"/>
               </a:rPr>
-              <a:t>Reasoning Agent</a:t>
+              <a:t>Classifier</a:t>
             </a:r>
             <a:endParaRPr lang="en-US" sz="1700" dirty="0"/>
           </a:p>
@@ -5612,13 +5358,13 @@
       </p:sp>
       <p:sp>
         <p:nvSpPr>
-          <p:cNvPr id="23" name="Text 16"/>
-          <p:cNvSpPr/>
-          <p:nvPr/>
-        </p:nvSpPr>
-        <p:spPr>
-          <a:xfrm>
-            <a:off x="8595360" y="3657600"/>
+          <p:cNvPr id="16" name="Text 11"/>
+          <p:cNvSpPr/>
+          <p:nvPr/>
+        </p:nvSpPr>
+        <p:spPr>
+          <a:xfrm>
+            <a:off x="4709160" y="3657600"/>
             <a:ext cx="2743200" cy="1371600"/>
           </a:xfrm>
           <a:prstGeom prst="rect">
@@ -5631,7 +5377,7 @@
           <a:bodyPr wrap="square" rtlCol="0" anchor="ctr"/>
           <a:lstStyle/>
           <a:p>
-            <a:pPr indent="0" marL="0">
+            <a:pPr marL="0" indent="0">
               <a:lnSpc>
                 <a:spcPct val="125000"/>
               </a:lnSpc>
@@ -5646,6 +5392,230 @@
                 <a:ea typeface="Calibri" pitchFamily="34" charset="-122"/>
                 <a:cs typeface="Calibri" pitchFamily="34" charset="-120"/>
               </a:rPr>
+              <a:t>Rule-based triage labels why a claim was flagged: upcoding, unbundling, duplicate billing.</a:t>
+            </a:r>
+            <a:endParaRPr lang="en-US" sz="1200" dirty="0"/>
+          </a:p>
+        </p:txBody>
+      </p:sp>
+      <p:pic>
+        <p:nvPicPr>
+          <p:cNvPr id="17" name="Image 3" descr="preencoded.png"/>
+          <p:cNvPicPr>
+            <a:picLocks noChangeAspect="1"/>
+          </p:cNvPicPr>
+          <p:nvPr/>
+        </p:nvPicPr>
+        <p:blipFill>
+          <a:blip r:embed="rId4"/>
+          <a:stretch>
+            <a:fillRect/>
+          </a:stretch>
+        </p:blipFill>
+        <p:spPr>
+          <a:xfrm>
+            <a:off x="7799832" y="3337560"/>
+            <a:ext cx="365760" cy="365760"/>
+          </a:xfrm>
+          <a:prstGeom prst="rect">
+            <a:avLst/>
+          </a:prstGeom>
+        </p:spPr>
+      </p:pic>
+      <p:sp>
+        <p:nvSpPr>
+          <p:cNvPr id="18" name="Shape 12"/>
+          <p:cNvSpPr/>
+          <p:nvPr/>
+        </p:nvSpPr>
+        <p:spPr>
+          <a:xfrm>
+            <a:off x="8321040" y="1920240"/>
+            <a:ext cx="3291840" cy="3200400"/>
+          </a:xfrm>
+          <a:prstGeom prst="roundRect">
+            <a:avLst>
+              <a:gd name="adj" fmla="val 2286"/>
+            </a:avLst>
+          </a:prstGeom>
+          <a:solidFill>
+            <a:srgbClr val="26316B"/>
+          </a:solidFill>
+          <a:ln/>
+        </p:spPr>
+        <p:txBody>
+          <a:bodyPr/>
+          <a:lstStyle/>
+          <a:p>
+            <a:endParaRPr lang="en-US"/>
+          </a:p>
+        </p:txBody>
+      </p:sp>
+      <p:sp>
+        <p:nvSpPr>
+          <p:cNvPr id="19" name="Shape 13"/>
+          <p:cNvSpPr/>
+          <p:nvPr/>
+        </p:nvSpPr>
+        <p:spPr>
+          <a:xfrm>
+            <a:off x="8595360" y="2194560"/>
+            <a:ext cx="640080" cy="640080"/>
+          </a:xfrm>
+          <a:prstGeom prst="ellipse">
+            <a:avLst/>
+          </a:prstGeom>
+          <a:solidFill>
+            <a:srgbClr val="00A896"/>
+          </a:solidFill>
+          <a:ln/>
+        </p:spPr>
+        <p:txBody>
+          <a:bodyPr/>
+          <a:lstStyle/>
+          <a:p>
+            <a:endParaRPr lang="en-US"/>
+          </a:p>
+        </p:txBody>
+      </p:sp>
+      <p:pic>
+        <p:nvPicPr>
+          <p:cNvPr id="20" name="Image 4" descr="preencoded.png"/>
+          <p:cNvPicPr>
+            <a:picLocks noChangeAspect="1"/>
+          </p:cNvPicPr>
+          <p:nvPr/>
+        </p:nvPicPr>
+        <p:blipFill>
+          <a:blip r:embed="rId6"/>
+          <a:stretch>
+            <a:fillRect/>
+          </a:stretch>
+        </p:blipFill>
+        <p:spPr>
+          <a:xfrm>
+            <a:off x="8741664" y="2340864"/>
+            <a:ext cx="347472" cy="347472"/>
+          </a:xfrm>
+          <a:prstGeom prst="rect">
+            <a:avLst/>
+          </a:prstGeom>
+        </p:spPr>
+      </p:pic>
+      <p:sp>
+        <p:nvSpPr>
+          <p:cNvPr id="21" name="Text 14"/>
+          <p:cNvSpPr/>
+          <p:nvPr/>
+        </p:nvSpPr>
+        <p:spPr>
+          <a:xfrm>
+            <a:off x="8595360" y="2926080"/>
+            <a:ext cx="2743200" cy="274320"/>
+          </a:xfrm>
+          <a:prstGeom prst="rect">
+            <a:avLst/>
+          </a:prstGeom>
+          <a:noFill/>
+          <a:ln/>
+        </p:spPr>
+        <p:txBody>
+          <a:bodyPr wrap="square" rtlCol="0" anchor="ctr"/>
+          <a:lstStyle/>
+          <a:p>
+            <a:pPr marL="0" indent="0">
+              <a:buNone/>
+            </a:pPr>
+            <a:r>
+              <a:rPr lang="en-US" sz="1200" b="1" kern="0" spc="100" dirty="0">
+                <a:solidFill>
+                  <a:srgbClr val="00A896"/>
+                </a:solidFill>
+                <a:latin typeface="Calibri" pitchFamily="34" charset="0"/>
+                <a:ea typeface="Calibri" pitchFamily="34" charset="-122"/>
+                <a:cs typeface="Calibri" pitchFamily="34" charset="-120"/>
+              </a:rPr>
+              <a:t>Agent 3</a:t>
+            </a:r>
+            <a:endParaRPr lang="en-US" sz="1200" dirty="0"/>
+          </a:p>
+        </p:txBody>
+      </p:sp>
+      <p:sp>
+        <p:nvSpPr>
+          <p:cNvPr id="22" name="Text 15"/>
+          <p:cNvSpPr/>
+          <p:nvPr/>
+        </p:nvSpPr>
+        <p:spPr>
+          <a:xfrm>
+            <a:off x="8595360" y="3200400"/>
+            <a:ext cx="2743200" cy="411480"/>
+          </a:xfrm>
+          <a:prstGeom prst="rect">
+            <a:avLst/>
+          </a:prstGeom>
+          <a:noFill/>
+          <a:ln/>
+        </p:spPr>
+        <p:txBody>
+          <a:bodyPr wrap="square" rtlCol="0" anchor="ctr"/>
+          <a:lstStyle/>
+          <a:p>
+            <a:pPr marL="0" indent="0">
+              <a:buNone/>
+            </a:pPr>
+            <a:r>
+              <a:rPr lang="en-US" sz="1700" b="1" dirty="0">
+                <a:solidFill>
+                  <a:srgbClr val="FFFFFF"/>
+                </a:solidFill>
+                <a:latin typeface="Calibri" pitchFamily="34" charset="0"/>
+                <a:ea typeface="Calibri" pitchFamily="34" charset="-122"/>
+                <a:cs typeface="Calibri" pitchFamily="34" charset="-120"/>
+              </a:rPr>
+              <a:t>Reasoning Agent</a:t>
+            </a:r>
+            <a:endParaRPr lang="en-US" sz="1700" dirty="0"/>
+          </a:p>
+        </p:txBody>
+      </p:sp>
+      <p:sp>
+        <p:nvSpPr>
+          <p:cNvPr id="23" name="Text 16"/>
+          <p:cNvSpPr/>
+          <p:nvPr/>
+        </p:nvSpPr>
+        <p:spPr>
+          <a:xfrm>
+            <a:off x="8595360" y="3657600"/>
+            <a:ext cx="2743200" cy="1371600"/>
+          </a:xfrm>
+          <a:prstGeom prst="rect">
+            <a:avLst/>
+          </a:prstGeom>
+          <a:noFill/>
+          <a:ln/>
+        </p:spPr>
+        <p:txBody>
+          <a:bodyPr wrap="square" rtlCol="0" anchor="ctr"/>
+          <a:lstStyle/>
+          <a:p>
+            <a:pPr marL="0" indent="0">
+              <a:lnSpc>
+                <a:spcPct val="125000"/>
+              </a:lnSpc>
+              <a:buNone/>
+            </a:pPr>
+            <a:r>
+              <a:rPr lang="en-US" sz="1200" dirty="0">
+                <a:solidFill>
+                  <a:srgbClr val="CADCFC"/>
+                </a:solidFill>
+                <a:latin typeface="Calibri" pitchFamily="34" charset="0"/>
+                <a:ea typeface="Calibri" pitchFamily="34" charset="-122"/>
+                <a:cs typeface="Calibri" pitchFamily="34" charset="-120"/>
+              </a:rPr>
               <a:t>LLM chains both signals into a written investigation summary and recommendation.</a:t>
             </a:r>
             <a:endParaRPr lang="en-US" sz="1200" dirty="0"/>
@@ -5673,7 +5643,7 @@
           <a:bodyPr wrap="square" rtlCol="0" anchor="ctr"/>
           <a:lstStyle/>
           <a:p>
-            <a:pPr indent="0" marL="0">
+            <a:pPr marL="0" indent="0">
               <a:buNone/>
             </a:pPr>
             <a:r>
@@ -5707,6 +5677,7 @@
         <a:solidFill>
           <a:srgbClr val="FFFFFF"/>
         </a:solidFill>
+        <a:effectLst/>
       </p:bgPr>
     </p:bg>
     <p:spTree>
@@ -5744,7 +5715,7 @@
           <a:bodyPr wrap="square" rtlCol="0" anchor="ctr"/>
           <a:lstStyle/>
           <a:p>
-            <a:pPr indent="0" marL="0">
+            <a:pPr marL="0" indent="0">
               <a:buNone/>
             </a:pPr>
             <a:r>
@@ -5783,7 +5754,7 @@
           <a:bodyPr wrap="square" rtlCol="0" anchor="ctr"/>
           <a:lstStyle/>
           <a:p>
-            <a:pPr indent="0" marL="0">
+            <a:pPr marL="0" indent="0">
               <a:buNone/>
             </a:pPr>
             <a:r>
@@ -5822,6 +5793,13 @@
           </a:solidFill>
           <a:ln/>
         </p:spPr>
+        <p:txBody>
+          <a:bodyPr/>
+          <a:lstStyle/>
+          <a:p>
+            <a:endParaRPr lang="en-US"/>
+          </a:p>
+        </p:txBody>
       </p:sp>
       <p:sp>
         <p:nvSpPr>
@@ -5844,7 +5822,7 @@
           <a:bodyPr wrap="square" rtlCol="0" anchor="ctr"/>
           <a:lstStyle/>
           <a:p>
-            <a:pPr algn="ctr" indent="0" marL="0">
+            <a:pPr marL="0" indent="0" algn="ctr">
               <a:buNone/>
             </a:pPr>
             <a:r>
@@ -5883,7 +5861,7 @@
           <a:bodyPr wrap="square" rtlCol="0" anchor="ctr"/>
           <a:lstStyle/>
           <a:p>
-            <a:pPr algn="ctr" indent="0" marL="0">
+            <a:pPr marL="0" indent="0" algn="ctr">
               <a:buNone/>
             </a:pPr>
             <a:r>
@@ -5922,6 +5900,13 @@
           </a:solidFill>
           <a:ln/>
         </p:spPr>
+        <p:txBody>
+          <a:bodyPr/>
+          <a:lstStyle/>
+          <a:p>
+            <a:endParaRPr lang="en-US"/>
+          </a:p>
+        </p:txBody>
       </p:sp>
       <p:sp>
         <p:nvSpPr>
@@ -5944,7 +5929,7 @@
           <a:bodyPr wrap="square" rtlCol="0" anchor="ctr"/>
           <a:lstStyle/>
           <a:p>
-            <a:pPr algn="ctr" indent="0" marL="0">
+            <a:pPr marL="0" indent="0" algn="ctr">
               <a:buNone/>
             </a:pPr>
             <a:r>
@@ -5983,7 +5968,7 @@
           <a:bodyPr wrap="square" rtlCol="0" anchor="ctr"/>
           <a:lstStyle/>
           <a:p>
-            <a:pPr algn="ctr" indent="0" marL="0">
+            <a:pPr marL="0" indent="0" algn="ctr">
               <a:buNone/>
             </a:pPr>
             <a:r>
@@ -6022,6 +6007,13 @@
           </a:solidFill>
           <a:ln/>
         </p:spPr>
+        <p:txBody>
+          <a:bodyPr/>
+          <a:lstStyle/>
+          <a:p>
+            <a:endParaRPr lang="en-US"/>
+          </a:p>
+        </p:txBody>
       </p:sp>
       <p:sp>
         <p:nvSpPr>
@@ -6044,7 +6036,7 @@
           <a:bodyPr wrap="square" rtlCol="0" anchor="ctr"/>
           <a:lstStyle/>
           <a:p>
-            <a:pPr algn="ctr" indent="0" marL="0">
+            <a:pPr marL="0" indent="0" algn="ctr">
               <a:buNone/>
             </a:pPr>
             <a:r>
@@ -6083,7 +6075,7 @@
           <a:bodyPr wrap="square" rtlCol="0" anchor="ctr"/>
           <a:lstStyle/>
           <a:p>
-            <a:pPr algn="ctr" indent="0" marL="0">
+            <a:pPr marL="0" indent="0" algn="ctr">
               <a:buNone/>
             </a:pPr>
             <a:r>
@@ -6127,17 +6119,24 @@
             <a:prstDash val="solid"/>
           </a:ln>
         </p:spPr>
+        <p:txBody>
+          <a:bodyPr/>
+          <a:lstStyle/>
+          <a:p>
+            <a:endParaRPr lang="en-US"/>
+          </a:p>
+        </p:txBody>
       </p:sp>
       <p:pic>
         <p:nvPicPr>
-          <p:cNvPr id="14" name="Image 0" descr="preencoded.png">    </p:cNvPr>
+          <p:cNvPr id="14" name="Image 0" descr="preencoded.png"/>
           <p:cNvPicPr>
             <a:picLocks noChangeAspect="1"/>
           </p:cNvPicPr>
           <p:nvPr/>
         </p:nvPicPr>
         <p:blipFill>
-          <a:blip r:embed="rId1"/>
+          <a:blip r:embed="rId3"/>
           <a:stretch>
             <a:fillRect/>
           </a:stretch>
@@ -6173,7 +6172,7 @@
           <a:bodyPr wrap="square" rtlCol="0" anchor="ctr"/>
           <a:lstStyle/>
           <a:p>
-            <a:pPr indent="0" marL="0">
+            <a:pPr marL="0" indent="0">
               <a:buNone/>
             </a:pPr>
             <a:r>
@@ -6212,7 +6211,7 @@
           <a:bodyPr wrap="square" rtlCol="0" anchor="ctr"/>
           <a:lstStyle/>
           <a:p>
-            <a:pPr indent="0" marL="0">
+            <a:pPr marL="0" indent="0">
               <a:lnSpc>
                 <a:spcPct val="130000"/>
               </a:lnSpc>
@@ -6254,7 +6253,7 @@
           <a:bodyPr wrap="square" rtlCol="0" anchor="ctr"/>
           <a:lstStyle/>
           <a:p>
-            <a:pPr indent="0" marL="0">
+            <a:pPr marL="0" indent="0">
               <a:buNone/>
             </a:pPr>
             <a:r>
@@ -6293,7 +6292,7 @@
           <a:bodyPr wrap="square" rtlCol="0" anchor="ctr"/>
           <a:lstStyle/>
           <a:p>
-            <a:pPr indent="0" marL="0">
+            <a:pPr marL="0" indent="0">
               <a:buNone/>
             </a:pPr>
             <a:r>
@@ -6327,6 +6326,7 @@
         <a:solidFill>
           <a:srgbClr val="FFFFFF"/>
         </a:solidFill>
+        <a:effectLst/>
       </p:bgPr>
     </p:bg>
     <p:spTree>
@@ -6364,7 +6364,7 @@
           <a:bodyPr wrap="square" rtlCol="0" anchor="ctr"/>
           <a:lstStyle/>
           <a:p>
-            <a:pPr indent="0" marL="0">
+            <a:pPr marL="0" indent="0">
               <a:buNone/>
             </a:pPr>
             <a:r>
@@ -6403,13 +6403,20 @@
           </a:solidFill>
           <a:ln/>
           <a:effectLst>
-            <a:outerShdw sx="100000" sy="100000" kx="0" ky="0" algn="bl" rotWithShape="0" blurRad="101600" dist="38100" dir="5400000">
+            <a:outerShdw blurRad="101600" dist="38100" dir="5400000" algn="bl" rotWithShape="0">
               <a:srgbClr val="1E2761">
                 <a:alpha val="10000"/>
               </a:srgbClr>
             </a:outerShdw>
           </a:effectLst>
         </p:spPr>
+        <p:txBody>
+          <a:bodyPr/>
+          <a:lstStyle/>
+          <a:p>
+            <a:endParaRPr lang="en-US"/>
+          </a:p>
+        </p:txBody>
       </p:sp>
       <p:sp>
         <p:nvSpPr>
@@ -6430,324 +6437,17 @@
           </a:solidFill>
           <a:ln/>
         </p:spPr>
+        <p:txBody>
+          <a:bodyPr/>
+          <a:lstStyle/>
+          <a:p>
+            <a:endParaRPr lang="en-US"/>
+          </a:p>
+        </p:txBody>
       </p:sp>
       <p:pic>
         <p:nvPicPr>
-          <p:cNvPr id="5" name="Image 0" descr="preencoded.png">    </p:cNvPr>
-          <p:cNvPicPr>
-            <a:picLocks noChangeAspect="1"/>
-          </p:cNvPicPr>
-          <p:nvPr/>
-        </p:nvPicPr>
-        <p:blipFill>
-          <a:blip r:embed="rId1"/>
-          <a:stretch>
-            <a:fillRect/>
-          </a:stretch>
-        </p:blipFill>
-        <p:spPr>
-          <a:xfrm>
-            <a:off x="1024128" y="2029968"/>
-            <a:ext cx="365760" cy="365760"/>
-          </a:xfrm>
-          <a:prstGeom prst="rect">
-            <a:avLst/>
-          </a:prstGeom>
-        </p:spPr>
-      </p:pic>
-      <p:sp>
-        <p:nvSpPr>
-          <p:cNvPr id="6" name="Text 3"/>
-          <p:cNvSpPr/>
-          <p:nvPr/>
-        </p:nvSpPr>
-        <p:spPr>
-          <a:xfrm>
-            <a:off x="822960" y="2743200"/>
-            <a:ext cx="2971800" cy="640080"/>
-          </a:xfrm>
-          <a:prstGeom prst="rect">
-            <a:avLst/>
-          </a:prstGeom>
-          <a:noFill/>
-          <a:ln/>
-        </p:spPr>
-        <p:txBody>
-          <a:bodyPr wrap="square" rtlCol="0" anchor="ctr"/>
-          <a:lstStyle/>
-          <a:p>
-            <a:pPr indent="0" marL="0">
-              <a:lnSpc>
-                <a:spcPct val="115000"/>
-              </a:lnSpc>
-              <a:buNone/>
-            </a:pPr>
-            <a:r>
-              <a:rPr lang="en-US" sz="1550" b="1" dirty="0">
-                <a:solidFill>
-                  <a:srgbClr val="1E2761"/>
-                </a:solidFill>
-                <a:latin typeface="Calibri" pitchFamily="34" charset="0"/>
-                <a:ea typeface="Calibri" pitchFamily="34" charset="-122"/>
-                <a:cs typeface="Calibri" pitchFamily="34" charset="-120"/>
-              </a:rPr>
-              <a:t>Agentic AI fits TPO naturally</a:t>
-            </a:r>
-            <a:endParaRPr lang="en-US" sz="1550" dirty="0"/>
-          </a:p>
-        </p:txBody>
-      </p:sp>
-      <p:sp>
-        <p:nvSpPr>
-          <p:cNvPr id="7" name="Text 4"/>
-          <p:cNvSpPr/>
-          <p:nvPr/>
-        </p:nvSpPr>
-        <p:spPr>
-          <a:xfrm>
-            <a:off x="822960" y="3429000"/>
-            <a:ext cx="2971800" cy="1828800"/>
-          </a:xfrm>
-          <a:prstGeom prst="rect">
-            <a:avLst/>
-          </a:prstGeom>
-          <a:noFill/>
-          <a:ln/>
-        </p:spPr>
-        <p:txBody>
-          <a:bodyPr wrap="square" rtlCol="0" anchor="ctr"/>
-          <a:lstStyle/>
-          <a:p>
-            <a:pPr indent="0" marL="0">
-              <a:lnSpc>
-                <a:spcPct val="125000"/>
-              </a:lnSpc>
-              <a:buNone/>
-            </a:pPr>
-            <a:r>
-              <a:rPr lang="en-US" sz="1250" dirty="0">
-                <a:solidFill>
-                  <a:srgbClr val="5B6B8C"/>
-                </a:solidFill>
-                <a:latin typeface="Calibri" pitchFamily="34" charset="0"/>
-                <a:ea typeface="Calibri" pitchFamily="34" charset="-122"/>
-                <a:cs typeface="Calibri" pitchFamily="34" charset="-120"/>
-              </a:rPr>
-              <a:t>Classification, anomaly detection, and chain reasoning map directly onto claims investigation workflows.</a:t>
-            </a:r>
-            <a:endParaRPr lang="en-US" sz="1250" dirty="0"/>
-          </a:p>
-        </p:txBody>
-      </p:sp>
-      <p:sp>
-        <p:nvSpPr>
-          <p:cNvPr id="8" name="Shape 5"/>
-          <p:cNvSpPr/>
-          <p:nvPr/>
-        </p:nvSpPr>
-        <p:spPr>
-          <a:xfrm>
-            <a:off x="4297680" y="1554480"/>
-            <a:ext cx="3520440" cy="3931920"/>
-          </a:xfrm>
-          <a:prstGeom prst="roundRect">
-            <a:avLst>
-              <a:gd name="adj" fmla="val 2078"/>
-            </a:avLst>
-          </a:prstGeom>
-          <a:solidFill>
-            <a:srgbClr val="F4F7FC"/>
-          </a:solidFill>
-          <a:ln/>
-          <a:effectLst>
-            <a:outerShdw sx="100000" sy="100000" kx="0" ky="0" algn="bl" rotWithShape="0" blurRad="101600" dist="38100" dir="5400000">
-              <a:srgbClr val="1E2761">
-                <a:alpha val="10000"/>
-              </a:srgbClr>
-            </a:outerShdw>
-          </a:effectLst>
-        </p:spPr>
-      </p:sp>
-      <p:sp>
-        <p:nvSpPr>
-          <p:cNvPr id="9" name="Shape 6"/>
-          <p:cNvSpPr/>
-          <p:nvPr/>
-        </p:nvSpPr>
-        <p:spPr>
-          <a:xfrm>
-            <a:off x="4617720" y="1874520"/>
-            <a:ext cx="685800" cy="685800"/>
-          </a:xfrm>
-          <a:prstGeom prst="ellipse">
-            <a:avLst/>
-          </a:prstGeom>
-          <a:solidFill>
-            <a:srgbClr val="1E2761"/>
-          </a:solidFill>
-          <a:ln/>
-        </p:spPr>
-      </p:sp>
-      <p:pic>
-        <p:nvPicPr>
-          <p:cNvPr id="10" name="Image 1" descr="preencoded.png">    </p:cNvPr>
-          <p:cNvPicPr>
-            <a:picLocks noChangeAspect="1"/>
-          </p:cNvPicPr>
-          <p:nvPr/>
-        </p:nvPicPr>
-        <p:blipFill>
-          <a:blip r:embed="rId2"/>
-          <a:stretch>
-            <a:fillRect/>
-          </a:stretch>
-        </p:blipFill>
-        <p:spPr>
-          <a:xfrm>
-            <a:off x="4773168" y="2029968"/>
-            <a:ext cx="365760" cy="365760"/>
-          </a:xfrm>
-          <a:prstGeom prst="rect">
-            <a:avLst/>
-          </a:prstGeom>
-        </p:spPr>
-      </p:pic>
-      <p:sp>
-        <p:nvSpPr>
-          <p:cNvPr id="11" name="Text 7"/>
-          <p:cNvSpPr/>
-          <p:nvPr/>
-        </p:nvSpPr>
-        <p:spPr>
-          <a:xfrm>
-            <a:off x="4572000" y="2743200"/>
-            <a:ext cx="2971800" cy="640080"/>
-          </a:xfrm>
-          <a:prstGeom prst="rect">
-            <a:avLst/>
-          </a:prstGeom>
-          <a:noFill/>
-          <a:ln/>
-        </p:spPr>
-        <p:txBody>
-          <a:bodyPr wrap="square" rtlCol="0" anchor="ctr"/>
-          <a:lstStyle/>
-          <a:p>
-            <a:pPr indent="0" marL="0">
-              <a:lnSpc>
-                <a:spcPct val="115000"/>
-              </a:lnSpc>
-              <a:buNone/>
-            </a:pPr>
-            <a:r>
-              <a:rPr lang="en-US" sz="1550" b="1" dirty="0">
-                <a:solidFill>
-                  <a:srgbClr val="1E2761"/>
-                </a:solidFill>
-                <a:latin typeface="Calibri" pitchFamily="34" charset="0"/>
-                <a:ea typeface="Calibri" pitchFamily="34" charset="-122"/>
-                <a:cs typeface="Calibri" pitchFamily="34" charset="-120"/>
-              </a:rPr>
-              <a:t>Governance is not optional</a:t>
-            </a:r>
-            <a:endParaRPr lang="en-US" sz="1550" dirty="0"/>
-          </a:p>
-        </p:txBody>
-      </p:sp>
-      <p:sp>
-        <p:nvSpPr>
-          <p:cNvPr id="12" name="Text 8"/>
-          <p:cNvSpPr/>
-          <p:nvPr/>
-        </p:nvSpPr>
-        <p:spPr>
-          <a:xfrm>
-            <a:off x="4572000" y="3429000"/>
-            <a:ext cx="2971800" cy="1828800"/>
-          </a:xfrm>
-          <a:prstGeom prst="rect">
-            <a:avLst/>
-          </a:prstGeom>
-          <a:noFill/>
-          <a:ln/>
-        </p:spPr>
-        <p:txBody>
-          <a:bodyPr wrap="square" rtlCol="0" anchor="ctr"/>
-          <a:lstStyle/>
-          <a:p>
-            <a:pPr indent="0" marL="0">
-              <a:lnSpc>
-                <a:spcPct val="125000"/>
-              </a:lnSpc>
-              <a:buNone/>
-            </a:pPr>
-            <a:r>
-              <a:rPr lang="en-US" sz="1250" dirty="0">
-                <a:solidFill>
-                  <a:srgbClr val="5B6B8C"/>
-                </a:solidFill>
-                <a:latin typeface="Calibri" pitchFamily="34" charset="0"/>
-                <a:ea typeface="Calibri" pitchFamily="34" charset="-122"/>
-                <a:cs typeface="Calibri" pitchFamily="34" charset="-120"/>
-              </a:rPr>
-              <a:t>Explainability and disclosure requirements are arriving in 2026 — build audit trails alongside the pilot, not after it.</a:t>
-            </a:r>
-            <a:endParaRPr lang="en-US" sz="1250" dirty="0"/>
-          </a:p>
-        </p:txBody>
-      </p:sp>
-      <p:sp>
-        <p:nvSpPr>
-          <p:cNvPr id="13" name="Shape 9"/>
-          <p:cNvSpPr/>
-          <p:nvPr/>
-        </p:nvSpPr>
-        <p:spPr>
-          <a:xfrm>
-            <a:off x="8046720" y="1554480"/>
-            <a:ext cx="3520440" cy="3931920"/>
-          </a:xfrm>
-          <a:prstGeom prst="roundRect">
-            <a:avLst>
-              <a:gd name="adj" fmla="val 2078"/>
-            </a:avLst>
-          </a:prstGeom>
-          <a:solidFill>
-            <a:srgbClr val="F4F7FC"/>
-          </a:solidFill>
-          <a:ln/>
-          <a:effectLst>
-            <a:outerShdw sx="100000" sy="100000" kx="0" ky="0" algn="bl" rotWithShape="0" blurRad="101600" dist="38100" dir="5400000">
-              <a:srgbClr val="1E2761">
-                <a:alpha val="10000"/>
-              </a:srgbClr>
-            </a:outerShdw>
-          </a:effectLst>
-        </p:spPr>
-      </p:sp>
-      <p:sp>
-        <p:nvSpPr>
-          <p:cNvPr id="14" name="Shape 10"/>
-          <p:cNvSpPr/>
-          <p:nvPr/>
-        </p:nvSpPr>
-        <p:spPr>
-          <a:xfrm>
-            <a:off x="8366760" y="1874520"/>
-            <a:ext cx="685800" cy="685800"/>
-          </a:xfrm>
-          <a:prstGeom prst="ellipse">
-            <a:avLst/>
-          </a:prstGeom>
-          <a:solidFill>
-            <a:srgbClr val="1E2761"/>
-          </a:solidFill>
-          <a:ln/>
-        </p:spPr>
-      </p:sp>
-      <p:pic>
-        <p:nvPicPr>
-          <p:cNvPr id="15" name="Image 2" descr="preencoded.png">    </p:cNvPr>
+          <p:cNvPr id="5" name="Image 0" descr="preencoded.png"/>
           <p:cNvPicPr>
             <a:picLocks noChangeAspect="1"/>
           </p:cNvPicPr>
@@ -6761,7 +6461,7 @@
         </p:blipFill>
         <p:spPr>
           <a:xfrm>
-            <a:off x="8522208" y="2029968"/>
+            <a:off x="1024128" y="2029968"/>
             <a:ext cx="365760" cy="365760"/>
           </a:xfrm>
           <a:prstGeom prst="rect">
@@ -6771,13 +6471,13 @@
       </p:pic>
       <p:sp>
         <p:nvSpPr>
-          <p:cNvPr id="16" name="Text 11"/>
-          <p:cNvSpPr/>
-          <p:nvPr/>
-        </p:nvSpPr>
-        <p:spPr>
-          <a:xfrm>
-            <a:off x="8321040" y="2743200"/>
+          <p:cNvPr id="6" name="Text 3"/>
+          <p:cNvSpPr/>
+          <p:nvPr/>
+        </p:nvSpPr>
+        <p:spPr>
+          <a:xfrm>
+            <a:off x="822960" y="2743200"/>
             <a:ext cx="2971800" cy="640080"/>
           </a:xfrm>
           <a:prstGeom prst="rect">
@@ -6790,7 +6490,7 @@
           <a:bodyPr wrap="square" rtlCol="0" anchor="ctr"/>
           <a:lstStyle/>
           <a:p>
-            <a:pPr indent="0" marL="0">
+            <a:pPr marL="0" indent="0">
               <a:lnSpc>
                 <a:spcPct val="115000"/>
               </a:lnSpc>
@@ -6805,6 +6505,348 @@
                 <a:ea typeface="Calibri" pitchFamily="34" charset="-122"/>
                 <a:cs typeface="Calibri" pitchFamily="34" charset="-120"/>
               </a:rPr>
+              <a:t>Agentic AI fits TPO naturally</a:t>
+            </a:r>
+            <a:endParaRPr lang="en-US" sz="1550" dirty="0"/>
+          </a:p>
+        </p:txBody>
+      </p:sp>
+      <p:sp>
+        <p:nvSpPr>
+          <p:cNvPr id="7" name="Text 4"/>
+          <p:cNvSpPr/>
+          <p:nvPr/>
+        </p:nvSpPr>
+        <p:spPr>
+          <a:xfrm>
+            <a:off x="822960" y="3429000"/>
+            <a:ext cx="2971800" cy="1828800"/>
+          </a:xfrm>
+          <a:prstGeom prst="rect">
+            <a:avLst/>
+          </a:prstGeom>
+          <a:noFill/>
+          <a:ln/>
+        </p:spPr>
+        <p:txBody>
+          <a:bodyPr wrap="square" rtlCol="0" anchor="ctr"/>
+          <a:lstStyle/>
+          <a:p>
+            <a:pPr marL="0" indent="0">
+              <a:lnSpc>
+                <a:spcPct val="125000"/>
+              </a:lnSpc>
+              <a:buNone/>
+            </a:pPr>
+            <a:r>
+              <a:rPr lang="en-US" sz="1250" dirty="0">
+                <a:solidFill>
+                  <a:srgbClr val="5B6B8C"/>
+                </a:solidFill>
+                <a:latin typeface="Calibri" pitchFamily="34" charset="0"/>
+                <a:ea typeface="Calibri" pitchFamily="34" charset="-122"/>
+                <a:cs typeface="Calibri" pitchFamily="34" charset="-120"/>
+              </a:rPr>
+              <a:t>Classification, anomaly detection, and chain reasoning map directly onto claims investigation workflows.</a:t>
+            </a:r>
+            <a:endParaRPr lang="en-US" sz="1250" dirty="0"/>
+          </a:p>
+        </p:txBody>
+      </p:sp>
+      <p:sp>
+        <p:nvSpPr>
+          <p:cNvPr id="8" name="Shape 5"/>
+          <p:cNvSpPr/>
+          <p:nvPr/>
+        </p:nvSpPr>
+        <p:spPr>
+          <a:xfrm>
+            <a:off x="4297680" y="1554480"/>
+            <a:ext cx="3520440" cy="3931920"/>
+          </a:xfrm>
+          <a:prstGeom prst="roundRect">
+            <a:avLst>
+              <a:gd name="adj" fmla="val 2078"/>
+            </a:avLst>
+          </a:prstGeom>
+          <a:solidFill>
+            <a:srgbClr val="F4F7FC"/>
+          </a:solidFill>
+          <a:ln/>
+          <a:effectLst>
+            <a:outerShdw blurRad="101600" dist="38100" dir="5400000" algn="bl" rotWithShape="0">
+              <a:srgbClr val="1E2761">
+                <a:alpha val="10000"/>
+              </a:srgbClr>
+            </a:outerShdw>
+          </a:effectLst>
+        </p:spPr>
+        <p:txBody>
+          <a:bodyPr/>
+          <a:lstStyle/>
+          <a:p>
+            <a:endParaRPr lang="en-US"/>
+          </a:p>
+        </p:txBody>
+      </p:sp>
+      <p:sp>
+        <p:nvSpPr>
+          <p:cNvPr id="9" name="Shape 6"/>
+          <p:cNvSpPr/>
+          <p:nvPr/>
+        </p:nvSpPr>
+        <p:spPr>
+          <a:xfrm>
+            <a:off x="4617720" y="1874520"/>
+            <a:ext cx="685800" cy="685800"/>
+          </a:xfrm>
+          <a:prstGeom prst="ellipse">
+            <a:avLst/>
+          </a:prstGeom>
+          <a:solidFill>
+            <a:srgbClr val="1E2761"/>
+          </a:solidFill>
+          <a:ln/>
+        </p:spPr>
+        <p:txBody>
+          <a:bodyPr/>
+          <a:lstStyle/>
+          <a:p>
+            <a:endParaRPr lang="en-US"/>
+          </a:p>
+        </p:txBody>
+      </p:sp>
+      <p:pic>
+        <p:nvPicPr>
+          <p:cNvPr id="10" name="Image 1" descr="preencoded.png"/>
+          <p:cNvPicPr>
+            <a:picLocks noChangeAspect="1"/>
+          </p:cNvPicPr>
+          <p:nvPr/>
+        </p:nvPicPr>
+        <p:blipFill>
+          <a:blip r:embed="rId4"/>
+          <a:stretch>
+            <a:fillRect/>
+          </a:stretch>
+        </p:blipFill>
+        <p:spPr>
+          <a:xfrm>
+            <a:off x="4773168" y="2029968"/>
+            <a:ext cx="365760" cy="365760"/>
+          </a:xfrm>
+          <a:prstGeom prst="rect">
+            <a:avLst/>
+          </a:prstGeom>
+        </p:spPr>
+      </p:pic>
+      <p:sp>
+        <p:nvSpPr>
+          <p:cNvPr id="11" name="Text 7"/>
+          <p:cNvSpPr/>
+          <p:nvPr/>
+        </p:nvSpPr>
+        <p:spPr>
+          <a:xfrm>
+            <a:off x="4572000" y="2743200"/>
+            <a:ext cx="2971800" cy="640080"/>
+          </a:xfrm>
+          <a:prstGeom prst="rect">
+            <a:avLst/>
+          </a:prstGeom>
+          <a:noFill/>
+          <a:ln/>
+        </p:spPr>
+        <p:txBody>
+          <a:bodyPr wrap="square" rtlCol="0" anchor="ctr"/>
+          <a:lstStyle/>
+          <a:p>
+            <a:pPr marL="0" indent="0">
+              <a:lnSpc>
+                <a:spcPct val="115000"/>
+              </a:lnSpc>
+              <a:buNone/>
+            </a:pPr>
+            <a:r>
+              <a:rPr lang="en-US" sz="1550" b="1" dirty="0">
+                <a:solidFill>
+                  <a:srgbClr val="1E2761"/>
+                </a:solidFill>
+                <a:latin typeface="Calibri" pitchFamily="34" charset="0"/>
+                <a:ea typeface="Calibri" pitchFamily="34" charset="-122"/>
+                <a:cs typeface="Calibri" pitchFamily="34" charset="-120"/>
+              </a:rPr>
+              <a:t>Governance is not optional</a:t>
+            </a:r>
+            <a:endParaRPr lang="en-US" sz="1550" dirty="0"/>
+          </a:p>
+        </p:txBody>
+      </p:sp>
+      <p:sp>
+        <p:nvSpPr>
+          <p:cNvPr id="12" name="Text 8"/>
+          <p:cNvSpPr/>
+          <p:nvPr/>
+        </p:nvSpPr>
+        <p:spPr>
+          <a:xfrm>
+            <a:off x="4572000" y="3429000"/>
+            <a:ext cx="2971800" cy="1828800"/>
+          </a:xfrm>
+          <a:prstGeom prst="rect">
+            <a:avLst/>
+          </a:prstGeom>
+          <a:noFill/>
+          <a:ln/>
+        </p:spPr>
+        <p:txBody>
+          <a:bodyPr wrap="square" rtlCol="0" anchor="ctr"/>
+          <a:lstStyle/>
+          <a:p>
+            <a:pPr marL="0" indent="0">
+              <a:lnSpc>
+                <a:spcPct val="125000"/>
+              </a:lnSpc>
+              <a:buNone/>
+            </a:pPr>
+            <a:r>
+              <a:rPr lang="en-US" sz="1250" dirty="0">
+                <a:solidFill>
+                  <a:srgbClr val="5B6B8C"/>
+                </a:solidFill>
+                <a:latin typeface="Calibri" pitchFamily="34" charset="0"/>
+                <a:ea typeface="Calibri" pitchFamily="34" charset="-122"/>
+                <a:cs typeface="Calibri" pitchFamily="34" charset="-120"/>
+              </a:rPr>
+              <a:t>Explainability and disclosure requirements are arriving in 2026 — build audit trails alongside the pilot, not after it.</a:t>
+            </a:r>
+            <a:endParaRPr lang="en-US" sz="1250" dirty="0"/>
+          </a:p>
+        </p:txBody>
+      </p:sp>
+      <p:sp>
+        <p:nvSpPr>
+          <p:cNvPr id="13" name="Shape 9"/>
+          <p:cNvSpPr/>
+          <p:nvPr/>
+        </p:nvSpPr>
+        <p:spPr>
+          <a:xfrm>
+            <a:off x="8046720" y="1554480"/>
+            <a:ext cx="3520440" cy="3931920"/>
+          </a:xfrm>
+          <a:prstGeom prst="roundRect">
+            <a:avLst>
+              <a:gd name="adj" fmla="val 2078"/>
+            </a:avLst>
+          </a:prstGeom>
+          <a:solidFill>
+            <a:srgbClr val="F4F7FC"/>
+          </a:solidFill>
+          <a:ln/>
+          <a:effectLst>
+            <a:outerShdw blurRad="101600" dist="38100" dir="5400000" algn="bl" rotWithShape="0">
+              <a:srgbClr val="1E2761">
+                <a:alpha val="10000"/>
+              </a:srgbClr>
+            </a:outerShdw>
+          </a:effectLst>
+        </p:spPr>
+        <p:txBody>
+          <a:bodyPr/>
+          <a:lstStyle/>
+          <a:p>
+            <a:endParaRPr lang="en-US"/>
+          </a:p>
+        </p:txBody>
+      </p:sp>
+      <p:sp>
+        <p:nvSpPr>
+          <p:cNvPr id="14" name="Shape 10"/>
+          <p:cNvSpPr/>
+          <p:nvPr/>
+        </p:nvSpPr>
+        <p:spPr>
+          <a:xfrm>
+            <a:off x="8366760" y="1874520"/>
+            <a:ext cx="685800" cy="685800"/>
+          </a:xfrm>
+          <a:prstGeom prst="ellipse">
+            <a:avLst/>
+          </a:prstGeom>
+          <a:solidFill>
+            <a:srgbClr val="1E2761"/>
+          </a:solidFill>
+          <a:ln/>
+        </p:spPr>
+        <p:txBody>
+          <a:bodyPr/>
+          <a:lstStyle/>
+          <a:p>
+            <a:endParaRPr lang="en-US"/>
+          </a:p>
+        </p:txBody>
+      </p:sp>
+      <p:pic>
+        <p:nvPicPr>
+          <p:cNvPr id="15" name="Image 2" descr="preencoded.png"/>
+          <p:cNvPicPr>
+            <a:picLocks noChangeAspect="1"/>
+          </p:cNvPicPr>
+          <p:nvPr/>
+        </p:nvPicPr>
+        <p:blipFill>
+          <a:blip r:embed="rId5"/>
+          <a:stretch>
+            <a:fillRect/>
+          </a:stretch>
+        </p:blipFill>
+        <p:spPr>
+          <a:xfrm>
+            <a:off x="8522208" y="2029968"/>
+            <a:ext cx="365760" cy="365760"/>
+          </a:xfrm>
+          <a:prstGeom prst="rect">
+            <a:avLst/>
+          </a:prstGeom>
+        </p:spPr>
+      </p:pic>
+      <p:sp>
+        <p:nvSpPr>
+          <p:cNvPr id="16" name="Text 11"/>
+          <p:cNvSpPr/>
+          <p:nvPr/>
+        </p:nvSpPr>
+        <p:spPr>
+          <a:xfrm>
+            <a:off x="8321040" y="2743200"/>
+            <a:ext cx="2971800" cy="640080"/>
+          </a:xfrm>
+          <a:prstGeom prst="rect">
+            <a:avLst/>
+          </a:prstGeom>
+          <a:noFill/>
+          <a:ln/>
+        </p:spPr>
+        <p:txBody>
+          <a:bodyPr wrap="square" rtlCol="0" anchor="ctr"/>
+          <a:lstStyle/>
+          <a:p>
+            <a:pPr marL="0" indent="0">
+              <a:lnSpc>
+                <a:spcPct val="115000"/>
+              </a:lnSpc>
+              <a:buNone/>
+            </a:pPr>
+            <a:r>
+              <a:rPr lang="en-US" sz="1550" b="1" dirty="0">
+                <a:solidFill>
+                  <a:srgbClr val="1E2761"/>
+                </a:solidFill>
+                <a:latin typeface="Calibri" pitchFamily="34" charset="0"/>
+                <a:ea typeface="Calibri" pitchFamily="34" charset="-122"/>
+                <a:cs typeface="Calibri" pitchFamily="34" charset="-120"/>
+              </a:rPr>
               <a:t>Start narrow, prove it, expand</a:t>
             </a:r>
             <a:endParaRPr lang="en-US" sz="1550" dirty="0"/>
@@ -6832,7 +6874,7 @@
           <a:bodyPr wrap="square" rtlCol="0" anchor="ctr"/>
           <a:lstStyle/>
           <a:p>
-            <a:pPr indent="0" marL="0">
+            <a:pPr marL="0" indent="0">
               <a:lnSpc>
                 <a:spcPct val="125000"/>
               </a:lnSpc>
@@ -7154,4 +7196,319 @@
     </a:ext>
   </a:extLst>
 </a:theme>
+</file>
+
+<file path=ppt/theme/theme2.xml><?xml version="1.0" encoding="utf-8"?>
+<a:theme xmlns:a="http://schemas.openxmlformats.org/drawingml/2006/main" name="Office Theme">
+  <a:themeElements>
+    <a:clrScheme name="Office">
+      <a:dk1>
+        <a:sysClr val="windowText" lastClr="000000"/>
+      </a:dk1>
+      <a:lt1>
+        <a:sysClr val="window" lastClr="FFFFFF"/>
+      </a:lt1>
+      <a:dk2>
+        <a:srgbClr val="0E2841"/>
+      </a:dk2>
+      <a:lt2>
+        <a:srgbClr val="E8E8E8"/>
+      </a:lt2>
+      <a:accent1>
+        <a:srgbClr val="156082"/>
+      </a:accent1>
+      <a:accent2>
+        <a:srgbClr val="E97132"/>
+      </a:accent2>
+      <a:accent3>
+        <a:srgbClr val="196B24"/>
+      </a:accent3>
+      <a:accent4>
+        <a:srgbClr val="0F9ED5"/>
+      </a:accent4>
+      <a:accent5>
+        <a:srgbClr val="A02B93"/>
+      </a:accent5>
+      <a:accent6>
+        <a:srgbClr val="4EA72E"/>
+      </a:accent6>
+      <a:hlink>
+        <a:srgbClr val="467886"/>
+      </a:hlink>
+      <a:folHlink>
+        <a:srgbClr val="96607D"/>
+      </a:folHlink>
+    </a:clrScheme>
+    <a:fontScheme name="Office">
+      <a:majorFont>
+        <a:latin typeface="Aptos Display" panose="02110004020202020204"/>
+        <a:ea typeface=""/>
+        <a:cs typeface=""/>
+        <a:font script="Jpan" typeface="游ゴシック Light"/>
+        <a:font script="Hang" typeface="맑은 고딕"/>
+        <a:font script="Hans" typeface="等线 Light"/>
+        <a:font script="Hant" typeface="新細明體"/>
+        <a:font script="Arab" typeface="Times New Roman"/>
+        <a:font script="Hebr" typeface="Times New Roman"/>
+        <a:font script="Thai" typeface="Angsana New"/>
+        <a:font script="Ethi" typeface="Nyala"/>
+        <a:font script="Beng" typeface="Vrinda"/>
+        <a:font script="Gujr" typeface="Shruti"/>
+        <a:font script="Khmr" typeface="MoolBoran"/>
+        <a:font script="Knda" typeface="Tunga"/>
+        <a:font script="Guru" typeface="Raavi"/>
+        <a:font script="Cans" typeface="Euphemia"/>
+        <a:font script="Cher" typeface="Plantagenet Cherokee"/>
+        <a:font script="Yiii" typeface="Microsoft Yi Baiti"/>
+        <a:font script="Tibt" typeface="Microsoft Himalaya"/>
+        <a:font script="Thaa" typeface="MV Boli"/>
+        <a:font script="Deva" typeface="Mangal"/>
+        <a:font script="Telu" typeface="Gautami"/>
+        <a:font script="Taml" typeface="Latha"/>
+        <a:font script="Syrc" typeface="Estrangelo Edessa"/>
+        <a:font script="Orya" typeface="Kalinga"/>
+        <a:font script="Mlym" typeface="Kartika"/>
+        <a:font script="Laoo" typeface="DokChampa"/>
+        <a:font script="Sinh" typeface="Iskoola Pota"/>
+        <a:font script="Mong" typeface="Mongolian Baiti"/>
+        <a:font script="Viet" typeface="Times New Roman"/>
+        <a:font script="Uigh" typeface="Microsoft Uighur"/>
+        <a:font script="Geor" typeface="Sylfaen"/>
+        <a:font script="Armn" typeface="Arial"/>
+        <a:font script="Bugi" typeface="Leelawadee UI"/>
+        <a:font script="Bopo" typeface="Microsoft JhengHei"/>
+        <a:font script="Java" typeface="Javanese Text"/>
+        <a:font script="Lisu" typeface="Segoe UI"/>
+        <a:font script="Mymr" typeface="Myanmar Text"/>
+        <a:font script="Nkoo" typeface="Ebrima"/>
+        <a:font script="Olck" typeface="Nirmala UI"/>
+        <a:font script="Osma" typeface="Ebrima"/>
+        <a:font script="Phag" typeface="Phagspa"/>
+        <a:font script="Syrn" typeface="Estrangelo Edessa"/>
+        <a:font script="Syrj" typeface="Estrangelo Edessa"/>
+        <a:font script="Syre" typeface="Estrangelo Edessa"/>
+        <a:font script="Sora" typeface="Nirmala UI"/>
+        <a:font script="Tale" typeface="Microsoft Tai Le"/>
+        <a:font script="Talu" typeface="Microsoft New Tai Lue"/>
+        <a:font script="Tfng" typeface="Ebrima"/>
+      </a:majorFont>
+      <a:minorFont>
+        <a:latin typeface="Aptos" panose="02110004020202020204"/>
+        <a:ea typeface=""/>
+        <a:cs typeface=""/>
+        <a:font script="Jpan" typeface="游ゴシック"/>
+        <a:font script="Hang" typeface="맑은 고딕"/>
+        <a:font script="Hans" typeface="等线"/>
+        <a:font script="Hant" typeface="新細明體"/>
+        <a:font script="Arab" typeface="Arial"/>
+        <a:font script="Hebr" typeface="Arial"/>
+        <a:font script="Thai" typeface="Cordia New"/>
+        <a:font script="Ethi" typeface="Nyala"/>
+        <a:font script="Beng" typeface="Vrinda"/>
+        <a:font script="Gujr" typeface="Shruti"/>
+        <a:font script="Khmr" typeface="DaunPenh"/>
+        <a:font script="Knda" typeface="Tunga"/>
+        <a:font script="Guru" typeface="Raavi"/>
+        <a:font script="Cans" typeface="Euphemia"/>
+        <a:font script="Cher" typeface="Plantagenet Cherokee"/>
+        <a:font script="Yiii" typeface="Microsoft Yi Baiti"/>
+        <a:font script="Tibt" typeface="Microsoft Himalaya"/>
+        <a:font script="Thaa" typeface="MV Boli"/>
+        <a:font script="Deva" typeface="Mangal"/>
+        <a:font script="Telu" typeface="Gautami"/>
+        <a:font script="Taml" typeface="Latha"/>
+        <a:font script="Syrc" typeface="Estrangelo Edessa"/>
+        <a:font script="Orya" typeface="Kalinga"/>
+        <a:font script="Mlym" typeface="Kartika"/>
+        <a:font script="Laoo" typeface="DokChampa"/>
+        <a:font script="Sinh" typeface="Iskoola Pota"/>
+        <a:font script="Mong" typeface="Mongolian Baiti"/>
+        <a:font script="Viet" typeface="Arial"/>
+        <a:font script="Uigh" typeface="Microsoft Uighur"/>
+        <a:font script="Geor" typeface="Sylfaen"/>
+        <a:font script="Armn" typeface="Arial"/>
+        <a:font script="Bugi" typeface="Leelawadee UI"/>
+        <a:font script="Bopo" typeface="Microsoft JhengHei"/>
+        <a:font script="Java" typeface="Javanese Text"/>
+        <a:font script="Lisu" typeface="Segoe UI"/>
+        <a:font script="Mymr" typeface="Myanmar Text"/>
+        <a:font script="Nkoo" typeface="Ebrima"/>
+        <a:font script="Olck" typeface="Nirmala UI"/>
+        <a:font script="Osma" typeface="Ebrima"/>
+        <a:font script="Phag" typeface="Phagspa"/>
+        <a:font script="Syrn" typeface="Estrangelo Edessa"/>
+        <a:font script="Syrj" typeface="Estrangelo Edessa"/>
+        <a:font script="Syre" typeface="Estrangelo Edessa"/>
+        <a:font script="Sora" typeface="Nirmala UI"/>
+        <a:font script="Tale" typeface="Microsoft Tai Le"/>
+        <a:font script="Talu" typeface="Microsoft New Tai Lue"/>
+        <a:font script="Tfng" typeface="Ebrima"/>
+      </a:minorFont>
+    </a:fontScheme>
+    <a:fmtScheme name="Office">
+      <a:fillStyleLst>
+        <a:solidFill>
+          <a:schemeClr val="phClr"/>
+        </a:solidFill>
+        <a:gradFill rotWithShape="1">
+          <a:gsLst>
+            <a:gs pos="0">
+              <a:schemeClr val="phClr">
+                <a:lumMod val="110000"/>
+                <a:satMod val="105000"/>
+                <a:tint val="67000"/>
+              </a:schemeClr>
+            </a:gs>
+            <a:gs pos="50000">
+              <a:schemeClr val="phClr">
+                <a:lumMod val="105000"/>
+                <a:satMod val="103000"/>
+                <a:tint val="73000"/>
+              </a:schemeClr>
+            </a:gs>
+            <a:gs pos="100000">
+              <a:schemeClr val="phClr">
+                <a:lumMod val="105000"/>
+                <a:satMod val="109000"/>
+                <a:tint val="81000"/>
+              </a:schemeClr>
+            </a:gs>
+          </a:gsLst>
+          <a:lin ang="5400000" scaled="0"/>
+        </a:gradFill>
+        <a:gradFill rotWithShape="1">
+          <a:gsLst>
+            <a:gs pos="0">
+              <a:schemeClr val="phClr">
+                <a:satMod val="103000"/>
+                <a:lumMod val="102000"/>
+                <a:tint val="94000"/>
+              </a:schemeClr>
+            </a:gs>
+            <a:gs pos="50000">
+              <a:schemeClr val="phClr">
+                <a:satMod val="110000"/>
+                <a:lumMod val="100000"/>
+                <a:shade val="100000"/>
+              </a:schemeClr>
+            </a:gs>
+            <a:gs pos="100000">
+              <a:schemeClr val="phClr">
+                <a:lumMod val="99000"/>
+                <a:satMod val="120000"/>
+                <a:shade val="78000"/>
+              </a:schemeClr>
+            </a:gs>
+          </a:gsLst>
+          <a:lin ang="5400000" scaled="0"/>
+        </a:gradFill>
+      </a:fillStyleLst>
+      <a:lnStyleLst>
+        <a:ln w="12700" cap="flat" cmpd="sng" algn="ctr">
+          <a:solidFill>
+            <a:schemeClr val="phClr"/>
+          </a:solidFill>
+          <a:prstDash val="solid"/>
+          <a:miter lim="800000"/>
+        </a:ln>
+        <a:ln w="19050" cap="flat" cmpd="sng" algn="ctr">
+          <a:solidFill>
+            <a:schemeClr val="phClr"/>
+          </a:solidFill>
+          <a:prstDash val="solid"/>
+          <a:miter lim="800000"/>
+        </a:ln>
+        <a:ln w="25400" cap="flat" cmpd="sng" algn="ctr">
+          <a:solidFill>
+            <a:schemeClr val="phClr"/>
+          </a:solidFill>
+          <a:prstDash val="solid"/>
+          <a:miter lim="800000"/>
+        </a:ln>
+      </a:lnStyleLst>
+      <a:effectStyleLst>
+        <a:effectStyle>
+          <a:effectLst/>
+        </a:effectStyle>
+        <a:effectStyle>
+          <a:effectLst/>
+        </a:effectStyle>
+        <a:effectStyle>
+          <a:effectLst>
+            <a:outerShdw blurRad="57150" dist="19050" dir="5400000" algn="ctr" rotWithShape="0">
+              <a:srgbClr val="000000">
+                <a:alpha val="63000"/>
+              </a:srgbClr>
+            </a:outerShdw>
+          </a:effectLst>
+        </a:effectStyle>
+      </a:effectStyleLst>
+      <a:bgFillStyleLst>
+        <a:solidFill>
+          <a:schemeClr val="phClr"/>
+        </a:solidFill>
+        <a:solidFill>
+          <a:schemeClr val="phClr">
+            <a:tint val="95000"/>
+            <a:satMod val="170000"/>
+          </a:schemeClr>
+        </a:solidFill>
+        <a:gradFill rotWithShape="1">
+          <a:gsLst>
+            <a:gs pos="0">
+              <a:schemeClr val="phClr">
+                <a:tint val="93000"/>
+                <a:satMod val="150000"/>
+                <a:shade val="98000"/>
+                <a:lumMod val="102000"/>
+              </a:schemeClr>
+            </a:gs>
+            <a:gs pos="50000">
+              <a:schemeClr val="phClr">
+                <a:tint val="98000"/>
+                <a:satMod val="130000"/>
+                <a:shade val="90000"/>
+                <a:lumMod val="103000"/>
+              </a:schemeClr>
+            </a:gs>
+            <a:gs pos="100000">
+              <a:schemeClr val="phClr">
+                <a:shade val="63000"/>
+                <a:satMod val="120000"/>
+              </a:schemeClr>
+            </a:gs>
+          </a:gsLst>
+          <a:lin ang="5400000" scaled="0"/>
+        </a:gradFill>
+      </a:bgFillStyleLst>
+    </a:fmtScheme>
+  </a:themeElements>
+  <a:objectDefaults>
+    <a:lnDef>
+      <a:spPr/>
+      <a:bodyPr/>
+      <a:lstStyle/>
+      <a:style>
+        <a:lnRef idx="2">
+          <a:schemeClr val="accent1"/>
+        </a:lnRef>
+        <a:fillRef idx="0">
+          <a:schemeClr val="accent1"/>
+        </a:fillRef>
+        <a:effectRef idx="1">
+          <a:schemeClr val="accent1"/>
+        </a:effectRef>
+        <a:fontRef idx="minor">
+          <a:schemeClr val="tx1"/>
+        </a:fontRef>
+      </a:style>
+    </a:lnDef>
+  </a:objectDefaults>
+  <a:extraClrSchemeLst/>
+  <a:extLst>
+    <a:ext uri="{05A4C25C-085E-4340-85A3-A5531E510DB2}">
+      <thm15:themeFamily xmlns:thm15="http://schemas.microsoft.com/office/thememl/2012/main" name="Office Theme" id="{2E142A2C-CD16-42D6-873A-C26D2A0506FA}" vid="{1BDDFF52-6CD6-40A5-AB3C-68EB2F1E4D0A}"/>
+    </a:ext>
+  </a:extLst>
+</a:theme>
 </file>
</xml_diff>